<commit_message>
chore: entrega la presentacion sin las notas del orador
El guion cumplio su proposito en la grabacion y el deck se entrega
limpio. Las 15 laminas quedan identicas; solo se vacian las notas, que
siguen disponibles en 4ce665e por si hicieran falta.

Co-authored-by: María Fassler Neumann <m.fasslerneumann@uandresbello.edu>
</commit_message>
<xml_diff>
--- a/S3/presentacion/Sumativa3_Presentacion_Grupo4.pptx
+++ b/S3/presentacion/Sumativa3_Presentacion_Grupo4.pptx
@@ -5,24 +5,24 @@
     <p:sldMasterId id="2147483684" r:id="rId1"/>
   </p:sldMasterIdLst>
   <p:notesMasterIdLst>
-    <p:notesMasterId r:id="rId9"/>
+    <p:notesMasterId r:id="rId17"/>
   </p:notesMasterIdLst>
   <p:sldIdLst>
     <p:sldId id="2076137175" r:id="rId2"/>
-    <p:sldId id="2076137361" r:id="rId15"/>
-    <p:sldId id="2076137362" r:id="rId16"/>
-    <p:sldId id="2076137363" r:id="rId17"/>
-    <p:sldId id="2076137364" r:id="rId18"/>
-    <p:sldId id="2076137365" r:id="rId19"/>
-    <p:sldId id="2076137366" r:id="rId20"/>
-    <p:sldId id="2076137367" r:id="rId21"/>
-    <p:sldId id="2076137368" r:id="rId22"/>
-    <p:sldId id="2076137369" r:id="rId23"/>
-    <p:sldId id="2076137370" r:id="rId24"/>
-    <p:sldId id="2076137371" r:id="rId25"/>
-    <p:sldId id="2076137372" r:id="rId26"/>
-    <p:sldId id="2076137373" r:id="rId27"/>
-    <p:sldId id="2076137374" r:id="rId28"/>
+    <p:sldId id="2076137361" r:id="rId3"/>
+    <p:sldId id="2076137362" r:id="rId4"/>
+    <p:sldId id="2076137363" r:id="rId5"/>
+    <p:sldId id="2076137364" r:id="rId6"/>
+    <p:sldId id="2076137365" r:id="rId7"/>
+    <p:sldId id="2076137366" r:id="rId8"/>
+    <p:sldId id="2076137367" r:id="rId9"/>
+    <p:sldId id="2076137368" r:id="rId10"/>
+    <p:sldId id="2076137369" r:id="rId11"/>
+    <p:sldId id="2076137370" r:id="rId12"/>
+    <p:sldId id="2076137371" r:id="rId13"/>
+    <p:sldId id="2076137372" r:id="rId14"/>
+    <p:sldId id="2076137373" r:id="rId15"/>
+    <p:sldId id="2076137374" r:id="rId16"/>
   </p:sldIdLst>
   <p:sldSz cx="12192000" cy="6858000"/>
   <p:notesSz cx="6858000" cy="9144000"/>
@@ -136,14 +136,19 @@
 </file>
 
 <file path=ppt/charts/chart1.xml><?xml version="1.0" encoding="utf-8"?>
-<c:chartSpace xmlns:c="http://schemas.openxmlformats.org/drawingml/2006/chart" xmlns:a="http://schemas.openxmlformats.org/drawingml/2006/main" xmlns:r="http://schemas.openxmlformats.org/officeDocument/2006/relationships">
+<c:chartSpace xmlns:c="http://schemas.openxmlformats.org/drawingml/2006/chart" xmlns:a="http://schemas.openxmlformats.org/drawingml/2006/main" xmlns:r="http://schemas.openxmlformats.org/officeDocument/2006/relationships" xmlns:c16r2="http://schemas.microsoft.com/office/drawing/2015/06/chart">
   <c:date1904 val="0"/>
+  <c:lang val="en-US"/>
+  <c:roundedCorners val="1"/>
+  <c:style val="2"/>
   <c:chart>
     <c:autoTitleDeleted val="1"/>
     <c:plotArea>
+      <c:layout/>
       <c:barChart>
         <c:barDir val="bar"/>
         <c:grouping val="clustered"/>
+        <c:varyColors val="1"/>
         <c:ser>
           <c:idx val="0"/>
           <c:order val="0"/>
@@ -163,6 +168,44 @@
               <a:srgbClr val="20236D"/>
             </a:solidFill>
           </c:spPr>
+          <c:invertIfNegative val="1"/>
+          <c:dLbls>
+            <c:numFmt formatCode="0.000" sourceLinked="0"/>
+            <c:spPr>
+              <a:noFill/>
+              <a:ln>
+                <a:noFill/>
+              </a:ln>
+              <a:effectLst/>
+            </c:spPr>
+            <c:txPr>
+              <a:bodyPr/>
+              <a:lstStyle/>
+              <a:p>
+                <a:pPr>
+                  <a:defRPr sz="1200" b="1">
+                    <a:solidFill>
+                      <a:srgbClr val="20236D"/>
+                    </a:solidFill>
+                  </a:defRPr>
+                </a:pPr>
+                <a:endParaRPr lang="es-CL"/>
+              </a:p>
+            </c:txPr>
+            <c:dLblPos val="outEnd"/>
+            <c:showLegendKey val="0"/>
+            <c:showVal val="1"/>
+            <c:showCatName val="0"/>
+            <c:showSerName val="0"/>
+            <c:showPercent val="0"/>
+            <c:showBubbleSize val="0"/>
+            <c:showLeaderLines val="0"/>
+            <c:extLst>
+              <c:ext xmlns:c15="http://schemas.microsoft.com/office/drawing/2012/chart" uri="{CE6537A1-D6FC-4f65-9D91-7224C49458BB}">
+                <c15:showLeaderLines val="0"/>
+              </c:ext>
+            </c:extLst>
+          </c:dLbls>
           <c:cat>
             <c:strRef>
               <c:f>Sheet1!$A$2:$A$5</c:f>
@@ -190,36 +233,36 @@
                 <c:formatCode>General</c:formatCode>
                 <c:ptCount val="4"/>
                 <c:pt idx="0">
-                  <c:v>0.762</c:v>
+                  <c:v>0.76200000000000001</c:v>
                 </c:pt>
                 <c:pt idx="1">
                   <c:v>0.72</c:v>
                 </c:pt>
                 <c:pt idx="2">
-                  <c:v>0.692</c:v>
+                  <c:v>0.69199999999999995</c:v>
                 </c:pt>
                 <c:pt idx="3">
-                  <c:v>0.633</c:v>
+                  <c:v>0.63300000000000001</c:v>
                 </c:pt>
               </c:numCache>
             </c:numRef>
           </c:val>
+          <c:extLst>
+            <c:ext xmlns:c14="http://schemas.microsoft.com/office/drawing/2007/8/2/chart" uri="{6F2FDCE9-48DA-4B69-8628-5D25D57E5C99}">
+              <c14:invertSolidFillFmt>
+                <c14:spPr xmlns:c14="http://schemas.microsoft.com/office/drawing/2007/8/2/chart">
+                  <a:solidFill>
+                    <a:srgbClr val="FFFFFF"/>
+                  </a:solidFill>
+                </c14:spPr>
+              </c14:invertSolidFillFmt>
+            </c:ext>
+            <c:ext xmlns:c16="http://schemas.microsoft.com/office/drawing/2014/chart" uri="{C3380CC4-5D6E-409C-BE32-E72D297353CC}">
+              <c16:uniqueId val="{00000000-0443-4149-A5F0-DBD111FC56DB}"/>
+            </c:ext>
+          </c:extLst>
         </c:ser>
         <c:dLbls>
-          <c:numFmt formatCode="0.000" sourceLinked="0"/>
-          <c:txPr>
-            <a:bodyPr/>
-            <a:lstStyle/>
-            <a:p>
-              <a:pPr>
-                <a:defRPr sz="1200" b="1">
-                  <a:solidFill>
-                    <a:srgbClr val="20236D"/>
-                  </a:solidFill>
-                </a:defRPr>
-              </a:pPr>
-            </a:p>
-          </c:txPr>
           <c:dLblPos val="outEnd"/>
           <c:showLegendKey val="0"/>
           <c:showVal val="1"/>
@@ -227,7 +270,6 @@
           <c:showSerName val="0"/>
           <c:showPercent val="0"/>
           <c:showBubbleSize val="0"/>
-          <c:showLeaderLines val="1"/>
         </c:dLbls>
         <c:gapWidth val="60"/>
         <c:axId val="-2068027336"/>
@@ -240,6 +282,7 @@
         </c:scaling>
         <c:delete val="0"/>
         <c:axPos val="l"/>
+        <c:numFmt formatCode="General" sourceLinked="0"/>
         <c:majorTickMark val="out"/>
         <c:minorTickMark val="none"/>
         <c:tickLblPos val="nextTo"/>
@@ -254,6 +297,7 @@
                 </a:solidFill>
               </a:defRPr>
             </a:pPr>
+            <a:endParaRPr lang="es-CL"/>
           </a:p>
         </c:txPr>
         <c:crossAx val="-2113994440"/>
@@ -266,8 +310,9 @@
       <c:valAx>
         <c:axId val="-2113994440"/>
         <c:scaling>
-          <c:max val="1.0"/>
-          <c:min val="0.0"/>
+          <c:orientation val="minMax"/>
+          <c:max val="1"/>
+          <c:min val="0"/>
         </c:scaling>
         <c:delete val="0"/>
         <c:axPos val="b"/>
@@ -286,13 +331,17 @@
                 </a:solidFill>
               </a:defRPr>
             </a:pPr>
+            <a:endParaRPr lang="es-CL"/>
           </a:p>
         </c:txPr>
         <c:crossAx val="-2068027336"/>
         <c:crosses val="autoZero"/>
+        <c:crossBetween val="between"/>
       </c:valAx>
     </c:plotArea>
+    <c:plotVisOnly val="1"/>
     <c:dispBlanksAs val="gap"/>
+    <c:showDLblsOverMax val="1"/>
   </c:chart>
   <c:txPr>
     <a:bodyPr/>
@@ -301,7 +350,7 @@
       <a:pPr>
         <a:defRPr sz="1800"/>
       </a:pPr>
-      <a:endParaRPr lang="en-US"/>
+      <a:endParaRPr lang="es-CL"/>
     </a:p>
   </c:txPr>
   <c:externalData r:id="rId1">
@@ -391,7 +440,7 @@
           </a:lstStyle>
           <a:p>
             <a:fld id="{B02B2D6A-D10B-4950-84AB-B76A76B41051}" type="datetimeFigureOut">
-              <a:t>06-07-26</a:t>
+              <a:t>27-10-2026</a:t>
             </a:fld>
             <a:endParaRPr lang="es-ES"/>
           </a:p>
@@ -548,7 +597,7 @@
           </a:lstStyle>
           <a:p>
             <a:fld id="{D32D85B4-8D15-40BA-BE63-8F85761BC2A6}" type="slidenum">
-              <a:t>‹Nº›</a:t>
+              <a:t>‹#›</a:t>
             </a:fld>
             <a:endParaRPr lang="es-ES"/>
           </a:p>
@@ -658,7 +707,7 @@
 </file>
 
 <file path=ppt/notesSlides/notesSlide1.xml><?xml version="1.0" encoding="utf-8"?>
-<p:notes xmlns:a="http://schemas.openxmlformats.org/drawingml/2006/main" xmlns:p="http://schemas.openxmlformats.org/presentationml/2006/main" xmlns:r="http://schemas.openxmlformats.org/officeDocument/2006/relationships">
+<p:notes xmlns:a="http://schemas.openxmlformats.org/drawingml/2006/main" xmlns:r="http://schemas.openxmlformats.org/officeDocument/2006/relationships" xmlns:p="http://schemas.openxmlformats.org/presentationml/2006/main">
   <p:cSld>
     <p:spTree>
       <p:nvGrpSpPr>
@@ -678,7 +727,7 @@
         <p:nvSpPr>
           <p:cNvPr id="2" name="Slide Image Placeholder 1"/>
           <p:cNvSpPr>
-            <a:spLocks noGrp="1"/>
+            <a:spLocks noGrp="1" noRot="1" noChangeAspect="1"/>
           </p:cNvSpPr>
           <p:nvPr>
             <p:ph type="sldImg" idx="2"/>
@@ -693,7 +742,7 @@
             <a:spLocks noGrp="1"/>
           </p:cNvSpPr>
           <p:nvPr>
-            <p:ph type="body" idx="3" sz="quarter"/>
+            <p:ph type="body" sz="quarter" idx="3"/>
           </p:nvPr>
         </p:nvSpPr>
         <p:spPr/>
@@ -701,15 +750,7 @@
           <a:bodyPr/>
           <a:lstStyle/>
           <a:p>
-            <a:r>
-              <a:t>[0:00 - 0:20]  Buenos dias. Presentamos el proyecto integrado sobre desercion en la educacion superior chilena. Somos Maria Fassler y Sebastian Antunez, Grupo 4.</a:t>
-            </a:r>
-          </a:p>
-          <a:p/>
-          <a:p>
-            <a:r>
-              <a:t>Esta fase no es un trabajo nuevo: es el cierre de una cadena que empezo en la Sumativa 1.</a:t>
-            </a:r>
+            <a:endParaRPr dirty="0"/>
           </a:p>
         </p:txBody>
       </p:sp>
@@ -720,7 +761,7 @@
             <a:spLocks noGrp="1"/>
           </p:cNvSpPr>
           <p:nvPr>
-            <p:ph type="sldNum" idx="5" sz="quarter"/>
+            <p:ph type="sldNum" sz="quarter" idx="5"/>
           </p:nvPr>
         </p:nvSpPr>
         <p:spPr/>
@@ -734,7 +775,7 @@
 </file>
 
 <file path=ppt/notesSlides/notesSlide10.xml><?xml version="1.0" encoding="utf-8"?>
-<p:notes xmlns:a="http://schemas.openxmlformats.org/drawingml/2006/main" xmlns:p="http://schemas.openxmlformats.org/presentationml/2006/main" xmlns:r="http://schemas.openxmlformats.org/officeDocument/2006/relationships">
+<p:notes xmlns:a="http://schemas.openxmlformats.org/drawingml/2006/main" xmlns:r="http://schemas.openxmlformats.org/officeDocument/2006/relationships" xmlns:p="http://schemas.openxmlformats.org/presentationml/2006/main">
   <p:cSld>
     <p:spTree>
       <p:nvGrpSpPr>
@@ -754,7 +795,7 @@
         <p:nvSpPr>
           <p:cNvPr id="2" name="Slide Image Placeholder 1"/>
           <p:cNvSpPr>
-            <a:spLocks noGrp="1"/>
+            <a:spLocks noGrp="1" noRot="1" noChangeAspect="1"/>
           </p:cNvSpPr>
           <p:nvPr>
             <p:ph type="sldImg" idx="2"/>
@@ -769,7 +810,7 @@
             <a:spLocks noGrp="1"/>
           </p:cNvSpPr>
           <p:nvPr>
-            <p:ph type="body" idx="3" sz="quarter"/>
+            <p:ph type="body" sz="quarter" idx="3"/>
           </p:nvPr>
         </p:nvSpPr>
         <p:spPr/>
@@ -777,27 +818,7 @@
           <a:bodyPr/>
           <a:lstStyle/>
           <a:p>
-            <a:r>
-              <a:t>[6:00 - 6:50]  Tercer resultado, y lo importante no es el numero del modelo sino con que se compara.</a:t>
-            </a:r>
-          </a:p>
-          <a:p/>
-          <a:p>
-            <a:r>
-              <a:t>La linea base predice siempre la clase mayoritaria: acierta el 54,9 por ciento y su F1 es 0,709, porque su sensibilidad es uno por construccion. El modelo sube la exactitud casi trece puntos y el AUC de 0,500 a 0,730: ahi esta la ganancia real.</a:t>
-            </a:r>
-          </a:p>
-          <a:p/>
-          <a:p>
-            <a:r>
-              <a:t>La pauta pide ponderacion de clase para mejorar el recall y sale al reves: la sensibilidad baja ocho puntos, porque la ponderacion rebaja el peso de la clase mayoritaria y aqui la positiva es la mayoritaria. El AUC no se mueve en ninguna fila: ninguna palanca cambia el orden, solo el punto de corte.</a:t>
-            </a:r>
-          </a:p>
-          <a:p/>
-          <a:p>
-            <a:r>
-              <a:t>La que si sube el recall es el umbral. Con 0,418 la sensibilidad llega a 0,850 y da el mejor F1 de todas, 0,740.</a:t>
-            </a:r>
+            <a:endParaRPr dirty="0"/>
           </a:p>
         </p:txBody>
       </p:sp>
@@ -808,7 +829,7 @@
             <a:spLocks noGrp="1"/>
           </p:cNvSpPr>
           <p:nvPr>
-            <p:ph type="sldNum" idx="5" sz="quarter"/>
+            <p:ph type="sldNum" sz="quarter" idx="5"/>
           </p:nvPr>
         </p:nvSpPr>
         <p:spPr/>
@@ -822,7 +843,7 @@
 </file>
 
 <file path=ppt/notesSlides/notesSlide11.xml><?xml version="1.0" encoding="utf-8"?>
-<p:notes xmlns:a="http://schemas.openxmlformats.org/drawingml/2006/main" xmlns:p="http://schemas.openxmlformats.org/presentationml/2006/main" xmlns:r="http://schemas.openxmlformats.org/officeDocument/2006/relationships">
+<p:notes xmlns:a="http://schemas.openxmlformats.org/drawingml/2006/main" xmlns:r="http://schemas.openxmlformats.org/officeDocument/2006/relationships" xmlns:p="http://schemas.openxmlformats.org/presentationml/2006/main">
   <p:cSld>
     <p:spTree>
       <p:nvGrpSpPr>
@@ -842,7 +863,7 @@
         <p:nvSpPr>
           <p:cNvPr id="2" name="Slide Image Placeholder 1"/>
           <p:cNvSpPr>
-            <a:spLocks noGrp="1"/>
+            <a:spLocks noGrp="1" noRot="1" noChangeAspect="1"/>
           </p:cNvSpPr>
           <p:nvPr>
             <p:ph type="sldImg" idx="2"/>
@@ -857,7 +878,7 @@
             <a:spLocks noGrp="1"/>
           </p:cNvSpPr>
           <p:nvPr>
-            <p:ph type="body" idx="3" sz="quarter"/>
+            <p:ph type="body" sz="quarter" idx="3"/>
           </p:nvPr>
         </p:nvSpPr>
         <p:spPr/>
@@ -865,27 +886,7 @@
           <a:bodyPr/>
           <a:lstStyle/>
           <a:p>
-            <a:r>
-              <a:t>[6:50 - 7:45]  Este es el resultado metodologico central, y es un contraste entre dos remuestreos.</a:t>
-            </a:r>
-          </a:p>
-          <a:p/>
-          <a:p>
-            <a:r>
-              <a:t>El primero es el bootstrap estandar, que remuestrea observaciones y es el que corresponde a la particion que usamos. Su resultado es tranquilizador: los intervalos reproducen casi exactamente los clasicos, con una razon entre 1,00 y 1,12. Es el mismo veredicto que la segunda sumativa dio sobre medias y correlaciones.</a:t>
-            </a:r>
-          </a:p>
-          <a:p/>
-          <a:p>
-            <a:r>
-              <a:t>El segundo remuestrea instituciones y arrastra todos sus programas. Ahi los intervalos se ensanchan entre 1,62 y 3,01 veces, y los coeficientes sin signo determinado suben de cuatro a siete de veinte.</a:t>
-            </a:r>
-          </a:p>
-          <a:p/>
-          <a:p>
-            <a:r>
-              <a:t>No se contradicen: responden a preguntas distintas. El primero dice que, si los programas fueran independientes, la precision declarada seria correcta. El segundo dice que no lo son, y que la precision real es entre dos y tres veces menor.</a:t>
-            </a:r>
+            <a:endParaRPr dirty="0"/>
           </a:p>
         </p:txBody>
       </p:sp>
@@ -896,7 +897,7 @@
             <a:spLocks noGrp="1"/>
           </p:cNvSpPr>
           <p:nvPr>
-            <p:ph type="sldNum" idx="5" sz="quarter"/>
+            <p:ph type="sldNum" sz="quarter" idx="5"/>
           </p:nvPr>
         </p:nvSpPr>
         <p:spPr/>
@@ -910,7 +911,7 @@
 </file>
 
 <file path=ppt/notesSlides/notesSlide12.xml><?xml version="1.0" encoding="utf-8"?>
-<p:notes xmlns:a="http://schemas.openxmlformats.org/drawingml/2006/main" xmlns:p="http://schemas.openxmlformats.org/presentationml/2006/main" xmlns:r="http://schemas.openxmlformats.org/officeDocument/2006/relationships">
+<p:notes xmlns:a="http://schemas.openxmlformats.org/drawingml/2006/main" xmlns:r="http://schemas.openxmlformats.org/officeDocument/2006/relationships" xmlns:p="http://schemas.openxmlformats.org/presentationml/2006/main">
   <p:cSld>
     <p:spTree>
       <p:nvGrpSpPr>
@@ -930,7 +931,7 @@
         <p:nvSpPr>
           <p:cNvPr id="2" name="Slide Image Placeholder 1"/>
           <p:cNvSpPr>
-            <a:spLocks noGrp="1"/>
+            <a:spLocks noGrp="1" noRot="1" noChangeAspect="1"/>
           </p:cNvSpPr>
           <p:nvPr>
             <p:ph type="sldImg" idx="2"/>
@@ -945,7 +946,7 @@
             <a:spLocks noGrp="1"/>
           </p:cNvSpPr>
           <p:nvPr>
-            <p:ph type="body" idx="3" sz="quarter"/>
+            <p:ph type="body" sz="quarter" idx="3"/>
           </p:nvPr>
         </p:nvSpPr>
         <p:spPr/>
@@ -953,33 +954,7 @@
           <a:bodyPr/>
           <a:lstStyle/>
           <a:p>
-            <a:r>
-              <a:t>[7:45 - 8:35]  El diagnostico deja dos cosas tranquilas y dos incomodas.</a:t>
-            </a:r>
-          </a:p>
-          <a:p/>
-          <a:p>
-            <a:r>
-              <a:t>Tranquilas: la colinealidad no es problema, los cuatro VIF estan bajo 1,21; y la calibracion es buena, porque la probabilidad predicha sigue la frecuencia observada por deciles.</a:t>
-            </a:r>
-          </a:p>
-          <a:p/>
-          <a:p>
-            <a:r>
-              <a:t>Incomodas, y las declaramos. Box-Tidwell rechaza la linealidad en el logit en tres de las cuatro variables continuas. El modelo lineal es una aproximacion y las razones de momios son efectos promedio.</a:t>
-            </a:r>
-          </a:p>
-          <a:p/>
-          <a:p>
-            <a:r>
-              <a:t>Y las observaciones influyentes: ninguna domina, la distancia de Cook maxima es 0,0095. Pero retirar las 237 que superan cuatro sobre n mueve el coeficiente de la acreditacion institucional casi un 88 por ciento.</a:t>
-            </a:r>
-          </a:p>
-          <a:p/>
-          <a:p>
-            <a:r>
-              <a:t>Eso concuerda con el bootstrap: es el coeficiente cuyo intervalo mas se ensancha. Es la variable de mayor efecto y la de menor solidez.</a:t>
-            </a:r>
+            <a:endParaRPr dirty="0"/>
           </a:p>
         </p:txBody>
       </p:sp>
@@ -990,7 +965,7 @@
             <a:spLocks noGrp="1"/>
           </p:cNvSpPr>
           <p:nvPr>
-            <p:ph type="sldNum" idx="5" sz="quarter"/>
+            <p:ph type="sldNum" sz="quarter" idx="5"/>
           </p:nvPr>
         </p:nvSpPr>
         <p:spPr/>
@@ -1004,7 +979,7 @@
 </file>
 
 <file path=ppt/notesSlides/notesSlide13.xml><?xml version="1.0" encoding="utf-8"?>
-<p:notes xmlns:a="http://schemas.openxmlformats.org/drawingml/2006/main" xmlns:p="http://schemas.openxmlformats.org/presentationml/2006/main" xmlns:r="http://schemas.openxmlformats.org/officeDocument/2006/relationships">
+<p:notes xmlns:a="http://schemas.openxmlformats.org/drawingml/2006/main" xmlns:r="http://schemas.openxmlformats.org/officeDocument/2006/relationships" xmlns:p="http://schemas.openxmlformats.org/presentationml/2006/main">
   <p:cSld>
     <p:spTree>
       <p:nvGrpSpPr>
@@ -1024,7 +999,7 @@
         <p:nvSpPr>
           <p:cNvPr id="2" name="Slide Image Placeholder 1"/>
           <p:cNvSpPr>
-            <a:spLocks noGrp="1"/>
+            <a:spLocks noGrp="1" noRot="1" noChangeAspect="1"/>
           </p:cNvSpPr>
           <p:nvPr>
             <p:ph type="sldImg" idx="2"/>
@@ -1039,7 +1014,7 @@
             <a:spLocks noGrp="1"/>
           </p:cNvSpPr>
           <p:nvPr>
-            <p:ph type="body" idx="3" sz="quarter"/>
+            <p:ph type="body" sz="quarter" idx="3"/>
           </p:nvPr>
         </p:nvSpPr>
         <p:spPr/>
@@ -1047,27 +1022,7 @@
           <a:bodyPr/>
           <a:lstStyle/>
           <a:p>
-            <a:r>
-              <a:t>[8:35 - 9:20]  Conclusiones, en dos columnas, porque un trabajo serio tiene que decir las dos cosas.</a:t>
-            </a:r>
-          </a:p>
-          <a:p/>
-          <a:p>
-            <a:r>
-              <a:t>Permite afirmar que el abandono aparente se asocia de forma robusta con la acreditacion, el tamano y la composicion de genero; que el modelo suma casi trece puntos sobre la linea base, de modo que sirve para priorizar; y que las cuatro variables que lo sostienen son las que resistieron el remuestreo en S2.</a:t>
-            </a:r>
-          </a:p>
-          <a:p/>
-          <a:p>
-            <a:r>
-              <a:t>No permite afirmar nada sobre estudiantes individuales, porque la unidad es el programa. Nada sobre causas, porque no hay grupo de control. Nada sobre el abandono real, porque medimos el aparente. Y nada firme sobre los efectos categoricos.</a:t>
-            </a:r>
-          </a:p>
-          <a:p/>
-          <a:p>
-            <a:r>
-              <a:t>Esa segunda columna es parte del resultado.</a:t>
-            </a:r>
+            <a:endParaRPr dirty="0"/>
           </a:p>
         </p:txBody>
       </p:sp>
@@ -1078,7 +1033,7 @@
             <a:spLocks noGrp="1"/>
           </p:cNvSpPr>
           <p:nvPr>
-            <p:ph type="sldNum" idx="5" sz="quarter"/>
+            <p:ph type="sldNum" sz="quarter" idx="5"/>
           </p:nvPr>
         </p:nvSpPr>
         <p:spPr/>
@@ -1092,7 +1047,7 @@
 </file>
 
 <file path=ppt/notesSlides/notesSlide14.xml><?xml version="1.0" encoding="utf-8"?>
-<p:notes xmlns:a="http://schemas.openxmlformats.org/drawingml/2006/main" xmlns:p="http://schemas.openxmlformats.org/presentationml/2006/main" xmlns:r="http://schemas.openxmlformats.org/officeDocument/2006/relationships">
+<p:notes xmlns:a="http://schemas.openxmlformats.org/drawingml/2006/main" xmlns:r="http://schemas.openxmlformats.org/officeDocument/2006/relationships" xmlns:p="http://schemas.openxmlformats.org/presentationml/2006/main">
   <p:cSld>
     <p:spTree>
       <p:nvGrpSpPr>
@@ -1112,7 +1067,7 @@
         <p:nvSpPr>
           <p:cNvPr id="2" name="Slide Image Placeholder 1"/>
           <p:cNvSpPr>
-            <a:spLocks noGrp="1"/>
+            <a:spLocks noGrp="1" noRot="1" noChangeAspect="1"/>
           </p:cNvSpPr>
           <p:nvPr>
             <p:ph type="sldImg" idx="2"/>
@@ -1127,7 +1082,7 @@
             <a:spLocks noGrp="1"/>
           </p:cNvSpPr>
           <p:nvPr>
-            <p:ph type="body" idx="3" sz="quarter"/>
+            <p:ph type="body" sz="quarter" idx="3"/>
           </p:nvPr>
         </p:nvSpPr>
         <p:spPr/>
@@ -1135,21 +1090,7 @@
           <a:bodyPr/>
           <a:lstStyle/>
           <a:p>
-            <a:r>
-              <a:t>[9:20 - 10:00]  Cierro con las recomendaciones. Cuatro sobre datos faltantes: preferir la imputacion por regresion; no eliminar casos cuando la ausencia no es MCAR; declarar siempre el mecanismo supuesto; y tratar como optimista todo intervalo posterior a una imputacion simple.</a:t>
-            </a:r>
-          </a:p>
-          <a:p/>
-          <a:p>
-            <a:r>
-              <a:t>Esa ultima lleva a la limitacion mas importante: ninguna de las dos imputaciones propaga la incertidumbre de haber imputado, y corregirlo exige imputacion multiple. Las otras dos extensiones son terminos no lineales donde Box-Tidwell los exige, y un modelo multinivel que trate la institucion como efecto aleatorio.</a:t>
-            </a:r>
-          </a:p>
-          <a:p/>
-          <a:p>
-            <a:r>
-              <a:t>S1 describio y midio, S2 puso a prueba y valido, y S3 modela y predice sobre lo que quedo en pie. Muchas gracias.</a:t>
-            </a:r>
+            <a:endParaRPr dirty="0"/>
           </a:p>
         </p:txBody>
       </p:sp>
@@ -1160,7 +1101,7 @@
             <a:spLocks noGrp="1"/>
           </p:cNvSpPr>
           <p:nvPr>
-            <p:ph type="sldNum" idx="5" sz="quarter"/>
+            <p:ph type="sldNum" sz="quarter" idx="5"/>
           </p:nvPr>
         </p:nvSpPr>
         <p:spPr/>
@@ -1174,7 +1115,7 @@
 </file>
 
 <file path=ppt/notesSlides/notesSlide15.xml><?xml version="1.0" encoding="utf-8"?>
-<p:notes xmlns:a="http://schemas.openxmlformats.org/drawingml/2006/main" xmlns:p="http://schemas.openxmlformats.org/presentationml/2006/main" xmlns:r="http://schemas.openxmlformats.org/officeDocument/2006/relationships">
+<p:notes xmlns:a="http://schemas.openxmlformats.org/drawingml/2006/main" xmlns:r="http://schemas.openxmlformats.org/officeDocument/2006/relationships" xmlns:p="http://schemas.openxmlformats.org/presentationml/2006/main">
   <p:cSld>
     <p:spTree>
       <p:nvGrpSpPr>
@@ -1194,7 +1135,7 @@
         <p:nvSpPr>
           <p:cNvPr id="2" name="Slide Image Placeholder 1"/>
           <p:cNvSpPr>
-            <a:spLocks noGrp="1"/>
+            <a:spLocks noGrp="1" noRot="1" noChangeAspect="1"/>
           </p:cNvSpPr>
           <p:nvPr>
             <p:ph type="sldImg" idx="2"/>
@@ -1209,7 +1150,7 @@
             <a:spLocks noGrp="1"/>
           </p:cNvSpPr>
           <p:nvPr>
-            <p:ph type="body" idx="3" sz="quarter"/>
+            <p:ph type="body" sz="quarter" idx="3"/>
           </p:nvPr>
         </p:nvSpPr>
         <p:spPr/>
@@ -1217,9 +1158,7 @@
           <a:bodyPr/>
           <a:lstStyle/>
           <a:p>
-            <a:r>
-              <a:t>Diapositiva de cierre. Agradecer y quedar disponible para preguntas.</a:t>
-            </a:r>
+            <a:endParaRPr dirty="0"/>
           </a:p>
         </p:txBody>
       </p:sp>
@@ -1230,7 +1169,7 @@
             <a:spLocks noGrp="1"/>
           </p:cNvSpPr>
           <p:nvPr>
-            <p:ph type="sldNum" idx="5" sz="quarter"/>
+            <p:ph type="sldNum" sz="quarter" idx="5"/>
           </p:nvPr>
         </p:nvSpPr>
         <p:spPr/>
@@ -1244,7 +1183,7 @@
 </file>
 
 <file path=ppt/notesSlides/notesSlide2.xml><?xml version="1.0" encoding="utf-8"?>
-<p:notes xmlns:a="http://schemas.openxmlformats.org/drawingml/2006/main" xmlns:p="http://schemas.openxmlformats.org/presentationml/2006/main" xmlns:r="http://schemas.openxmlformats.org/officeDocument/2006/relationships">
+<p:notes xmlns:a="http://schemas.openxmlformats.org/drawingml/2006/main" xmlns:r="http://schemas.openxmlformats.org/officeDocument/2006/relationships" xmlns:p="http://schemas.openxmlformats.org/presentationml/2006/main">
   <p:cSld>
     <p:spTree>
       <p:nvGrpSpPr>
@@ -1264,7 +1203,7 @@
         <p:nvSpPr>
           <p:cNvPr id="2" name="Slide Image Placeholder 1"/>
           <p:cNvSpPr>
-            <a:spLocks noGrp="1"/>
+            <a:spLocks noGrp="1" noRot="1" noChangeAspect="1"/>
           </p:cNvSpPr>
           <p:nvPr>
             <p:ph type="sldImg" idx="2"/>
@@ -1279,7 +1218,7 @@
             <a:spLocks noGrp="1"/>
           </p:cNvSpPr>
           <p:nvPr>
-            <p:ph type="body" idx="3" sz="quarter"/>
+            <p:ph type="body" sz="quarter" idx="3"/>
           </p:nvPr>
         </p:nvSpPr>
         <p:spPr/>
@@ -1287,27 +1226,7 @@
           <a:bodyPr/>
           <a:lstStyle/>
           <a:p>
-            <a:r>
-              <a:t>[0:20 - 1:30]  El conjunto reune 9.678 programas de pregrado, construidos desde las bases abiertas del SIES: matricula 2007-2026 y titulados 2007-2025. El abandono aparente medio es 0,518, con una dispersion enorme entre programas. Si todos se parecieran, no habria nada que predecir.</a:t>
-            </a:r>
-          </a:p>
-          <a:p/>
-          <a:p>
-            <a:r>
-              <a:t>El tercer numero condiciona toda la metodologia: esos programas pertenecen a solo 168 instituciones. Los programas de una misma universidad no son independientes, y ese hecho reaparece al final como el resultado central de la fase.</a:t>
-            </a:r>
-          </a:p>
-          <a:p/>
-          <a:p>
-            <a:r>
-              <a:t>La pregunta practica es si el abandono puede anticiparse con atributos observables del programa, para focalizar recursos de retencion.</a:t>
-            </a:r>
-          </a:p>
-          <a:p/>
-          <a:p>
-            <a:r>
-              <a:t>Y dos advertencias de entrada, no al final. La unidad es el programa, no el estudiante: nada de lo que digamos aplica a una persona concreta. Y medimos abandono aparente: quien se cambia de carrera y se titula en otra parte, aqui cuenta como abandono.</a:t>
-            </a:r>
+            <a:endParaRPr dirty="0"/>
           </a:p>
         </p:txBody>
       </p:sp>
@@ -1318,7 +1237,7 @@
             <a:spLocks noGrp="1"/>
           </p:cNvSpPr>
           <p:nvPr>
-            <p:ph type="sldNum" idx="5" sz="quarter"/>
+            <p:ph type="sldNum" sz="quarter" idx="5"/>
           </p:nvPr>
         </p:nvSpPr>
         <p:spPr/>
@@ -1332,7 +1251,7 @@
 </file>
 
 <file path=ppt/notesSlides/notesSlide3.xml><?xml version="1.0" encoding="utf-8"?>
-<p:notes xmlns:a="http://schemas.openxmlformats.org/drawingml/2006/main" xmlns:p="http://schemas.openxmlformats.org/presentationml/2006/main" xmlns:r="http://schemas.openxmlformats.org/officeDocument/2006/relationships">
+<p:notes xmlns:a="http://schemas.openxmlformats.org/drawingml/2006/main" xmlns:r="http://schemas.openxmlformats.org/officeDocument/2006/relationships" xmlns:p="http://schemas.openxmlformats.org/presentationml/2006/main">
   <p:cSld>
     <p:spTree>
       <p:nvGrpSpPr>
@@ -1352,7 +1271,7 @@
         <p:nvSpPr>
           <p:cNvPr id="2" name="Slide Image Placeholder 1"/>
           <p:cNvSpPr>
-            <a:spLocks noGrp="1"/>
+            <a:spLocks noGrp="1" noRot="1" noChangeAspect="1"/>
           </p:cNvSpPr>
           <p:nvPr>
             <p:ph type="sldImg" idx="2"/>
@@ -1367,7 +1286,7 @@
             <a:spLocks noGrp="1"/>
           </p:cNvSpPr>
           <p:nvPr>
-            <p:ph type="body" idx="3" sz="quarter"/>
+            <p:ph type="body" sz="quarter" idx="3"/>
           </p:nvPr>
         </p:nvSpPr>
         <p:spPr/>
@@ -1375,9 +1294,7 @@
           <a:bodyPr/>
           <a:lstStyle/>
           <a:p>
-            <a:r>
-              <a:t>[1:30 - 1:40]  Paso a la metodologia. La idea es simple: ninguna decision de esta fase es nueva, todas vienen de un resultado de las fases anteriores.</a:t>
-            </a:r>
+            <a:endParaRPr dirty="0"/>
           </a:p>
         </p:txBody>
       </p:sp>
@@ -1388,7 +1305,7 @@
             <a:spLocks noGrp="1"/>
           </p:cNvSpPr>
           <p:nvPr>
-            <p:ph type="sldNum" idx="5" sz="quarter"/>
+            <p:ph type="sldNum" sz="quarter" idx="5"/>
           </p:nvPr>
         </p:nvSpPr>
         <p:spPr/>
@@ -1402,7 +1319,7 @@
 </file>
 
 <file path=ppt/notesSlides/notesSlide4.xml><?xml version="1.0" encoding="utf-8"?>
-<p:notes xmlns:a="http://schemas.openxmlformats.org/drawingml/2006/main" xmlns:p="http://schemas.openxmlformats.org/presentationml/2006/main" xmlns:r="http://schemas.openxmlformats.org/officeDocument/2006/relationships">
+<p:notes xmlns:a="http://schemas.openxmlformats.org/drawingml/2006/main" xmlns:r="http://schemas.openxmlformats.org/officeDocument/2006/relationships" xmlns:p="http://schemas.openxmlformats.org/presentationml/2006/main">
   <p:cSld>
     <p:spTree>
       <p:nvGrpSpPr>
@@ -1422,7 +1339,7 @@
         <p:nvSpPr>
           <p:cNvPr id="2" name="Slide Image Placeholder 1"/>
           <p:cNvSpPr>
-            <a:spLocks noGrp="1"/>
+            <a:spLocks noGrp="1" noRot="1" noChangeAspect="1"/>
           </p:cNvSpPr>
           <p:nvPr>
             <p:ph type="sldImg" idx="2"/>
@@ -1437,7 +1354,7 @@
             <a:spLocks noGrp="1"/>
           </p:cNvSpPr>
           <p:nvPr>
-            <p:ph type="body" idx="3" sz="quarter"/>
+            <p:ph type="body" sz="quarter" idx="3"/>
           </p:nvPr>
         </p:nvSpPr>
         <p:spPr/>
@@ -1445,21 +1362,7 @@
           <a:bodyPr/>
           <a:lstStyle/>
           <a:p>
-            <a:r>
-              <a:t>[1:40 - 2:30]  La primera sumativa describio y midio: abandono medio 0,518, nueve variables asociadas, 465 programas censurados y cero datos faltantes. Todo con procedimientos clasicos y supuestos sin verificar.</a:t>
-            </a:r>
-          </a:p>
-          <a:p/>
-          <a:p>
-            <a:r>
-              <a:t>La segunda lo puso a prueba. El bootstrap confirmo que los intervalos clasicos eran fiables. La permutacion valido el contraste sin suponer normalidad. La evaluacion de estabilidad separo las correlaciones solidas de las debiles. Y advirtio que los programas de una institucion no son independientes.</a:t>
-            </a:r>
-          </a:p>
-          <a:p/>
-          <a:p>
-            <a:r>
-              <a:t>Esta tercera fase integra todo eso en un modelo predictivo. Cada punto de la columna derecha es consecuencia directa de las dos anteriores.</a:t>
-            </a:r>
+            <a:endParaRPr dirty="0"/>
           </a:p>
         </p:txBody>
       </p:sp>
@@ -1470,7 +1373,7 @@
             <a:spLocks noGrp="1"/>
           </p:cNvSpPr>
           <p:nvPr>
-            <p:ph type="sldNum" idx="5" sz="quarter"/>
+            <p:ph type="sldNum" sz="quarter" idx="5"/>
           </p:nvPr>
         </p:nvSpPr>
         <p:spPr/>
@@ -1484,7 +1387,7 @@
 </file>
 
 <file path=ppt/notesSlides/notesSlide5.xml><?xml version="1.0" encoding="utf-8"?>
-<p:notes xmlns:a="http://schemas.openxmlformats.org/drawingml/2006/main" xmlns:p="http://schemas.openxmlformats.org/presentationml/2006/main" xmlns:r="http://schemas.openxmlformats.org/officeDocument/2006/relationships">
+<p:notes xmlns:a="http://schemas.openxmlformats.org/drawingml/2006/main" xmlns:r="http://schemas.openxmlformats.org/officeDocument/2006/relationships" xmlns:p="http://schemas.openxmlformats.org/presentationml/2006/main">
   <p:cSld>
     <p:spTree>
       <p:nvGrpSpPr>
@@ -1504,7 +1407,7 @@
         <p:nvSpPr>
           <p:cNvPr id="2" name="Slide Image Placeholder 1"/>
           <p:cNvSpPr>
-            <a:spLocks noGrp="1"/>
+            <a:spLocks noGrp="1" noRot="1" noChangeAspect="1"/>
           </p:cNvSpPr>
           <p:nvPr>
             <p:ph type="sldImg" idx="2"/>
@@ -1519,7 +1422,7 @@
             <a:spLocks noGrp="1"/>
           </p:cNvSpPr>
           <p:nvPr>
-            <p:ph type="body" idx="3" sz="quarter"/>
+            <p:ph type="body" sz="quarter" idx="3"/>
           </p:nvPr>
         </p:nvSpPr>
         <p:spPr/>
@@ -1527,21 +1430,7 @@
           <a:bodyPr/>
           <a:lstStyle/>
           <a:p>
-            <a:r>
-              <a:t>[2:30 - 3:20]  Esta tabla es la trazabilidad completa, y responde directamente a lo que la pauta exige demostrar.</a:t>
-            </a:r>
-          </a:p>
-          <a:p/>
-          <a:p>
-            <a:r>
-              <a:t>Las predictoras de los imputadores salieron de la matriz de correlaciones de S1. Las variables del modelo, del filtro de estabilidad de S2. Conservar los 465 censurados viene de la auditoria caso a caso que hizo S2, que encontro que el 91 por ciento de los que tienen abandono uno son cierres reales de programa. El umbral del 50 por ciento es el de S1, validado por intervalo de Wilson y contraste Z en S2. Y el bootstrap por institucion, que presentamos como extension, viene de la advertencia de S2 sobre la no independencia.</a:t>
-            </a:r>
-          </a:p>
-          <a:p/>
-          <a:p>
-            <a:r>
-              <a:t>No hay ninguna decision a la izquierda sin antecedente a la derecha.</a:t>
-            </a:r>
+            <a:endParaRPr dirty="0"/>
           </a:p>
         </p:txBody>
       </p:sp>
@@ -1552,7 +1441,7 @@
             <a:spLocks noGrp="1"/>
           </p:cNvSpPr>
           <p:nvPr>
-            <p:ph type="sldNum" idx="5" sz="quarter"/>
+            <p:ph type="sldNum" sz="quarter" idx="5"/>
           </p:nvPr>
         </p:nvSpPr>
         <p:spPr/>
@@ -1566,7 +1455,7 @@
 </file>
 
 <file path=ppt/notesSlides/notesSlide6.xml><?xml version="1.0" encoding="utf-8"?>
-<p:notes xmlns:a="http://schemas.openxmlformats.org/drawingml/2006/main" xmlns:p="http://schemas.openxmlformats.org/presentationml/2006/main" xmlns:r="http://schemas.openxmlformats.org/officeDocument/2006/relationships">
+<p:notes xmlns:a="http://schemas.openxmlformats.org/drawingml/2006/main" xmlns:r="http://schemas.openxmlformats.org/officeDocument/2006/relationships" xmlns:p="http://schemas.openxmlformats.org/presentationml/2006/main">
   <p:cSld>
     <p:spTree>
       <p:nvGrpSpPr>
@@ -1586,7 +1475,7 @@
         <p:nvSpPr>
           <p:cNvPr id="2" name="Slide Image Placeholder 1"/>
           <p:cNvSpPr>
-            <a:spLocks noGrp="1"/>
+            <a:spLocks noGrp="1" noRot="1" noChangeAspect="1"/>
           </p:cNvSpPr>
           <p:nvPr>
             <p:ph type="sldImg" idx="2"/>
@@ -1601,7 +1490,7 @@
             <a:spLocks noGrp="1"/>
           </p:cNvSpPr>
           <p:nvPr>
-            <p:ph type="body" idx="3" sz="quarter"/>
+            <p:ph type="body" sz="quarter" idx="3"/>
           </p:nvPr>
         </p:nvSpPr>
         <p:spPr/>
@@ -1609,21 +1498,7 @@
           <a:bodyPr/>
           <a:lstStyle/>
           <a:p>
-            <a:r>
-              <a:t>[3:20 - 4:10]  Aqui hay que ser transparentes. La pauta pide imputar datos faltantes y S1 habia demostrado que no hay ninguno; mas aun, nunca los hubo, porque cada fila es un agregado por programa.</a:t>
-            </a:r>
-          </a:p>
-          <a:p/>
-          <a:p>
-            <a:r>
-              <a:t>La pauta prescribe el procedimiento para ese caso: una o dos variables, entre el 10 y el 15 por ciento, MCAR y semilla fija. Eso se cumple en la edad promedio, que pierde el 14,9 por ciento al azar; MAR y MNAR los declaramos extension voluntaria. La ventaja del diseno es decisiva: conocemos los valores verdaderos y podemos medir el error de cada estrategia.</a:t>
-            </a:r>
-          </a:p>
-          <a:p/>
-          <a:p>
-            <a:r>
-              <a:t>Y la leccion no es la esperada. Bajo MNAR el sesgo es grande, pero bajo MAR es practicamente cero, porque la duracion apenas correlaciona con la variable afectada. MAR no sesga necesariamente las medias: distorsiona las relaciones condicionales.</a:t>
-            </a:r>
+            <a:endParaRPr dirty="0"/>
           </a:p>
         </p:txBody>
       </p:sp>
@@ -1634,7 +1509,7 @@
             <a:spLocks noGrp="1"/>
           </p:cNvSpPr>
           <p:nvPr>
-            <p:ph type="sldNum" idx="5" sz="quarter"/>
+            <p:ph type="sldNum" sz="quarter" idx="5"/>
           </p:nvPr>
         </p:nvSpPr>
         <p:spPr/>
@@ -1648,7 +1523,7 @@
 </file>
 
 <file path=ppt/notesSlides/notesSlide7.xml><?xml version="1.0" encoding="utf-8"?>
-<p:notes xmlns:a="http://schemas.openxmlformats.org/drawingml/2006/main" xmlns:p="http://schemas.openxmlformats.org/presentationml/2006/main" xmlns:r="http://schemas.openxmlformats.org/officeDocument/2006/relationships">
+<p:notes xmlns:a="http://schemas.openxmlformats.org/drawingml/2006/main" xmlns:r="http://schemas.openxmlformats.org/officeDocument/2006/relationships" xmlns:p="http://schemas.openxmlformats.org/presentationml/2006/main">
   <p:cSld>
     <p:spTree>
       <p:nvGrpSpPr>
@@ -1668,7 +1543,7 @@
         <p:nvSpPr>
           <p:cNvPr id="2" name="Slide Image Placeholder 1"/>
           <p:cNvSpPr>
-            <a:spLocks noGrp="1"/>
+            <a:spLocks noGrp="1" noRot="1" noChangeAspect="1"/>
           </p:cNvSpPr>
           <p:nvPr>
             <p:ph type="sldImg" idx="2"/>
@@ -1683,7 +1558,7 @@
             <a:spLocks noGrp="1"/>
           </p:cNvSpPr>
           <p:nvPr>
-            <p:ph type="body" idx="3" sz="quarter"/>
+            <p:ph type="body" sz="quarter" idx="3"/>
           </p:nvPr>
         </p:nvSpPr>
         <p:spPr/>
@@ -1691,9 +1566,7 @@
           <a:bodyPr/>
           <a:lstStyle/>
           <a:p>
-            <a:r>
-              <a:t>[4:10 - 4:20]  Paso a los resultados. Son cuatro, y el ultimo es el mas importante desde el punto de vista metodologico.</a:t>
-            </a:r>
+            <a:endParaRPr dirty="0"/>
           </a:p>
         </p:txBody>
       </p:sp>
@@ -1704,7 +1577,7 @@
             <a:spLocks noGrp="1"/>
           </p:cNvSpPr>
           <p:nvPr>
-            <p:ph type="sldNum" idx="5" sz="quarter"/>
+            <p:ph type="sldNum" sz="quarter" idx="5"/>
           </p:nvPr>
         </p:nvSpPr>
         <p:spPr/>
@@ -1718,7 +1591,7 @@
 </file>
 
 <file path=ppt/notesSlides/notesSlide8.xml><?xml version="1.0" encoding="utf-8"?>
-<p:notes xmlns:a="http://schemas.openxmlformats.org/drawingml/2006/main" xmlns:p="http://schemas.openxmlformats.org/presentationml/2006/main" xmlns:r="http://schemas.openxmlformats.org/officeDocument/2006/relationships">
+<p:notes xmlns:a="http://schemas.openxmlformats.org/drawingml/2006/main" xmlns:r="http://schemas.openxmlformats.org/officeDocument/2006/relationships" xmlns:p="http://schemas.openxmlformats.org/presentationml/2006/main">
   <p:cSld>
     <p:spTree>
       <p:nvGrpSpPr>
@@ -1738,7 +1611,7 @@
         <p:nvSpPr>
           <p:cNvPr id="2" name="Slide Image Placeholder 1"/>
           <p:cNvSpPr>
-            <a:spLocks noGrp="1"/>
+            <a:spLocks noGrp="1" noRot="1" noChangeAspect="1"/>
           </p:cNvSpPr>
           <p:nvPr>
             <p:ph type="sldImg" idx="2"/>
@@ -1753,7 +1626,7 @@
             <a:spLocks noGrp="1"/>
           </p:cNvSpPr>
           <p:nvPr>
-            <p:ph type="body" idx="3" sz="quarter"/>
+            <p:ph type="body" sz="quarter" idx="3"/>
           </p:nvPr>
         </p:nvSpPr>
         <p:spPr/>
@@ -1761,27 +1634,7 @@
           <a:bodyPr/>
           <a:lstStyle/>
           <a:p>
-            <a:r>
-              <a:t>[4:20 - 5:10]  Primer resultado: comparamos eliminar los casos, imputar por la mediana e imputar por regresion.</a:t>
-            </a:r>
-          </a:p>
-          <a:p/>
-          <a:p>
-            <a:r>
-              <a:t>La regresion gana en las tres dimensiones que importan. Conserva toda la muestra, mientras que eliminar deja solo el 47,5 por ciento, y no al azar: se pierden los programas de mayor duracion y los pequenos, asi que el conjunto superviviente deja de representar al sistema. Preserva mejor las correlaciones que S1 estimo. Y comete menos error contra los valores verdaderos.</a:t>
-            </a:r>
-          </a:p>
-          <a:p/>
-          <a:p>
-            <a:r>
-              <a:t>En la figura se ve por que la mediana es la peor: concentra toda la masa en un punto y atenua las asociaciones.</a:t>
-            </a:r>
-          </a:p>
-          <a:p/>
-          <a:p>
-            <a:r>
-              <a:t>Dos honestidades: donde el imputador no tiene poder predictivo la ventaja es minima, y bajo MNAR ninguna estrategia elimina el sesgo.</a:t>
-            </a:r>
+            <a:endParaRPr dirty="0"/>
           </a:p>
         </p:txBody>
       </p:sp>
@@ -1792,7 +1645,7 @@
             <a:spLocks noGrp="1"/>
           </p:cNvSpPr>
           <p:nvPr>
-            <p:ph type="sldNum" idx="5" sz="quarter"/>
+            <p:ph type="sldNum" sz="quarter" idx="5"/>
           </p:nvPr>
         </p:nvSpPr>
         <p:spPr/>
@@ -1806,7 +1659,7 @@
 </file>
 
 <file path=ppt/notesSlides/notesSlide9.xml><?xml version="1.0" encoding="utf-8"?>
-<p:notes xmlns:a="http://schemas.openxmlformats.org/drawingml/2006/main" xmlns:p="http://schemas.openxmlformats.org/presentationml/2006/main" xmlns:r="http://schemas.openxmlformats.org/officeDocument/2006/relationships">
+<p:notes xmlns:a="http://schemas.openxmlformats.org/drawingml/2006/main" xmlns:r="http://schemas.openxmlformats.org/officeDocument/2006/relationships" xmlns:p="http://schemas.openxmlformats.org/presentationml/2006/main">
   <p:cSld>
     <p:spTree>
       <p:nvGrpSpPr>
@@ -1826,7 +1679,7 @@
         <p:nvSpPr>
           <p:cNvPr id="2" name="Slide Image Placeholder 1"/>
           <p:cNvSpPr>
-            <a:spLocks noGrp="1"/>
+            <a:spLocks noGrp="1" noRot="1" noChangeAspect="1"/>
           </p:cNvSpPr>
           <p:nvPr>
             <p:ph type="sldImg" idx="2"/>
@@ -1841,7 +1694,7 @@
             <a:spLocks noGrp="1"/>
           </p:cNvSpPr>
           <p:nvPr>
-            <p:ph type="body" idx="3" sz="quarter"/>
+            <p:ph type="body" sz="quarter" idx="3"/>
           </p:nvPr>
         </p:nvSpPr>
         <p:spPr/>
@@ -1849,27 +1702,7 @@
           <a:bodyPr/>
           <a:lstStyle/>
           <a:p>
-            <a:r>
-              <a:t>[5:10 - 6:00]  Segundo resultado: cuatro variables sostienen la capacidad predictiva, y las cuatro protegen.</a:t>
-            </a:r>
-          </a:p>
-          <a:p/>
-          <a:p>
-            <a:r>
-              <a:t>Acreditacion institucional, razon de momios 0,633; acreditacion de la carrera, 0,692; tamano del programa, 0,720; proporcion de mujeres, 0,762. Como estan estandarizadas, cada numero es el efecto de una desviacion tipica: entre un 24 y un 37 por ciento menos de probabilidad relativa de abandono alto. Las cuatro son significativas al 0,1 por ciento.</a:t>
-            </a:r>
-          </a:p>
-          <a:p/>
-          <a:p>
-            <a:r>
-              <a:t>Y cada una entra al modelo con su cifra, no con una afirmacion vaga: su correlacion en la primera sumativa y su intervalo bootstrap en la segunda, que en los cuatro casos excluye el cero.</a:t>
-            </a:r>
-          </a:p>
-          <a:p/>
-          <a:p>
-            <a:r>
-              <a:t>La corroboracion viene de que construimos tres modelos con criterios distintos (dominio, stepwise por AIC y reducido) y los tres retienen exactamente estas cuatro variables continuas.</a:t>
-            </a:r>
+            <a:endParaRPr dirty="0"/>
           </a:p>
         </p:txBody>
       </p:sp>
@@ -1880,7 +1713,7 @@
             <a:spLocks noGrp="1"/>
           </p:cNvSpPr>
           <p:nvPr>
-            <p:ph type="sldNum" idx="5" sz="quarter"/>
+            <p:ph type="sldNum" sz="quarter" idx="5"/>
           </p:nvPr>
         </p:nvSpPr>
         <p:spPr/>
@@ -2024,7 +1857,7 @@
           <a:p>
             <a:fld id="{7DC156A5-B668-40B6-B68E-AFC99CB3A359}" type="datetimeFigureOut">
               <a:rPr lang="es-CL" smtClean="0"/>
-              <a:t>06-07-26</a:t>
+              <a:t>27-10-2026</a:t>
             </a:fld>
             <a:endParaRPr lang="es-CL"/>
           </a:p>
@@ -2066,7 +1899,7 @@
           <a:p>
             <a:fld id="{524E32BF-339A-4FD7-AF2D-884DBB49ECE9}" type="slidenum">
               <a:rPr lang="es-CL" smtClean="0"/>
-              <a:t>‹Nº›</a:t>
+              <a:t>‹#›</a:t>
             </a:fld>
             <a:endParaRPr lang="es-CL"/>
           </a:p>
@@ -2194,7 +2027,7 @@
           <a:p>
             <a:fld id="{7DC156A5-B668-40B6-B68E-AFC99CB3A359}" type="datetimeFigureOut">
               <a:rPr lang="es-CL" smtClean="0"/>
-              <a:t>06-07-26</a:t>
+              <a:t>27-10-2026</a:t>
             </a:fld>
             <a:endParaRPr lang="es-CL"/>
           </a:p>
@@ -2236,7 +2069,7 @@
           <a:p>
             <a:fld id="{524E32BF-339A-4FD7-AF2D-884DBB49ECE9}" type="slidenum">
               <a:rPr lang="es-CL" smtClean="0"/>
-              <a:t>‹Nº›</a:t>
+              <a:t>‹#›</a:t>
             </a:fld>
             <a:endParaRPr lang="es-CL"/>
           </a:p>
@@ -2374,7 +2207,7 @@
           <a:p>
             <a:fld id="{7DC156A5-B668-40B6-B68E-AFC99CB3A359}" type="datetimeFigureOut">
               <a:rPr lang="es-CL" smtClean="0"/>
-              <a:t>06-07-26</a:t>
+              <a:t>27-10-2026</a:t>
             </a:fld>
             <a:endParaRPr lang="es-CL"/>
           </a:p>
@@ -2416,7 +2249,7 @@
           <a:p>
             <a:fld id="{524E32BF-339A-4FD7-AF2D-884DBB49ECE9}" type="slidenum">
               <a:rPr lang="es-CL" smtClean="0"/>
-              <a:t>‹Nº›</a:t>
+              <a:t>‹#›</a:t>
             </a:fld>
             <a:endParaRPr lang="es-CL"/>
           </a:p>
@@ -2544,7 +2377,7 @@
           <a:p>
             <a:fld id="{7DC156A5-B668-40B6-B68E-AFC99CB3A359}" type="datetimeFigureOut">
               <a:rPr lang="es-CL" smtClean="0"/>
-              <a:t>06-07-26</a:t>
+              <a:t>27-10-2026</a:t>
             </a:fld>
             <a:endParaRPr lang="es-CL"/>
           </a:p>
@@ -2586,7 +2419,7 @@
           <a:p>
             <a:fld id="{524E32BF-339A-4FD7-AF2D-884DBB49ECE9}" type="slidenum">
               <a:rPr lang="es-CL" smtClean="0"/>
-              <a:t>‹Nº›</a:t>
+              <a:t>‹#›</a:t>
             </a:fld>
             <a:endParaRPr lang="es-CL"/>
           </a:p>
@@ -2790,7 +2623,7 @@
           <a:p>
             <a:fld id="{7DC156A5-B668-40B6-B68E-AFC99CB3A359}" type="datetimeFigureOut">
               <a:rPr lang="es-CL" smtClean="0"/>
-              <a:t>06-07-26</a:t>
+              <a:t>27-10-2026</a:t>
             </a:fld>
             <a:endParaRPr lang="es-CL"/>
           </a:p>
@@ -2832,7 +2665,7 @@
           <a:p>
             <a:fld id="{524E32BF-339A-4FD7-AF2D-884DBB49ECE9}" type="slidenum">
               <a:rPr lang="es-CL" smtClean="0"/>
-              <a:t>‹Nº›</a:t>
+              <a:t>‹#›</a:t>
             </a:fld>
             <a:endParaRPr lang="es-CL"/>
           </a:p>
@@ -3022,7 +2855,7 @@
           <a:p>
             <a:fld id="{7DC156A5-B668-40B6-B68E-AFC99CB3A359}" type="datetimeFigureOut">
               <a:rPr lang="es-CL" smtClean="0"/>
-              <a:t>06-07-26</a:t>
+              <a:t>27-10-2026</a:t>
             </a:fld>
             <a:endParaRPr lang="es-CL"/>
           </a:p>
@@ -3064,7 +2897,7 @@
           <a:p>
             <a:fld id="{524E32BF-339A-4FD7-AF2D-884DBB49ECE9}" type="slidenum">
               <a:rPr lang="es-CL" smtClean="0"/>
-              <a:t>‹Nº›</a:t>
+              <a:t>‹#›</a:t>
             </a:fld>
             <a:endParaRPr lang="es-CL"/>
           </a:p>
@@ -3389,7 +3222,7 @@
           <a:p>
             <a:fld id="{7DC156A5-B668-40B6-B68E-AFC99CB3A359}" type="datetimeFigureOut">
               <a:rPr lang="es-CL" smtClean="0"/>
-              <a:t>06-07-26</a:t>
+              <a:t>27-10-2026</a:t>
             </a:fld>
             <a:endParaRPr lang="es-CL"/>
           </a:p>
@@ -3431,7 +3264,7 @@
           <a:p>
             <a:fld id="{524E32BF-339A-4FD7-AF2D-884DBB49ECE9}" type="slidenum">
               <a:rPr lang="es-CL" smtClean="0"/>
-              <a:t>‹Nº›</a:t>
+              <a:t>‹#›</a:t>
             </a:fld>
             <a:endParaRPr lang="es-CL"/>
           </a:p>
@@ -3507,7 +3340,7 @@
           <a:p>
             <a:fld id="{7DC156A5-B668-40B6-B68E-AFC99CB3A359}" type="datetimeFigureOut">
               <a:rPr lang="es-CL" smtClean="0"/>
-              <a:t>06-07-26</a:t>
+              <a:t>27-10-2026</a:t>
             </a:fld>
             <a:endParaRPr lang="es-CL"/>
           </a:p>
@@ -3549,7 +3382,7 @@
           <a:p>
             <a:fld id="{524E32BF-339A-4FD7-AF2D-884DBB49ECE9}" type="slidenum">
               <a:rPr lang="es-CL" smtClean="0"/>
-              <a:t>‹Nº›</a:t>
+              <a:t>‹#›</a:t>
             </a:fld>
             <a:endParaRPr lang="es-CL"/>
           </a:p>
@@ -3602,7 +3435,7 @@
           <a:p>
             <a:fld id="{7DC156A5-B668-40B6-B68E-AFC99CB3A359}" type="datetimeFigureOut">
               <a:rPr lang="es-CL" smtClean="0"/>
-              <a:t>06-07-26</a:t>
+              <a:t>27-10-2026</a:t>
             </a:fld>
             <a:endParaRPr lang="es-CL"/>
           </a:p>
@@ -3644,7 +3477,7 @@
           <a:p>
             <a:fld id="{524E32BF-339A-4FD7-AF2D-884DBB49ECE9}" type="slidenum">
               <a:rPr lang="es-CL" smtClean="0"/>
-              <a:t>‹Nº›</a:t>
+              <a:t>‹#›</a:t>
             </a:fld>
             <a:endParaRPr lang="es-CL"/>
           </a:p>
@@ -3879,7 +3712,7 @@
           <a:p>
             <a:fld id="{7DC156A5-B668-40B6-B68E-AFC99CB3A359}" type="datetimeFigureOut">
               <a:rPr lang="es-CL" smtClean="0"/>
-              <a:t>06-07-26</a:t>
+              <a:t>27-10-2026</a:t>
             </a:fld>
             <a:endParaRPr lang="es-CL"/>
           </a:p>
@@ -3921,7 +3754,7 @@
           <a:p>
             <a:fld id="{524E32BF-339A-4FD7-AF2D-884DBB49ECE9}" type="slidenum">
               <a:rPr lang="es-CL" smtClean="0"/>
-              <a:t>‹Nº›</a:t>
+              <a:t>‹#›</a:t>
             </a:fld>
             <a:endParaRPr lang="es-CL"/>
           </a:p>
@@ -4136,7 +3969,7 @@
           <a:p>
             <a:fld id="{7DC156A5-B668-40B6-B68E-AFC99CB3A359}" type="datetimeFigureOut">
               <a:rPr lang="es-CL" smtClean="0"/>
-              <a:t>06-07-26</a:t>
+              <a:t>27-10-2026</a:t>
             </a:fld>
             <a:endParaRPr lang="es-CL"/>
           </a:p>
@@ -4178,7 +4011,7 @@
           <a:p>
             <a:fld id="{524E32BF-339A-4FD7-AF2D-884DBB49ECE9}" type="slidenum">
               <a:rPr lang="es-CL" smtClean="0"/>
-              <a:t>‹Nº›</a:t>
+              <a:t>‹#›</a:t>
             </a:fld>
             <a:endParaRPr lang="es-CL"/>
           </a:p>
@@ -4349,7 +4182,7 @@
           <a:p>
             <a:fld id="{7DC156A5-B668-40B6-B68E-AFC99CB3A359}" type="datetimeFigureOut">
               <a:rPr lang="es-CL" smtClean="0"/>
-              <a:t>06-07-26</a:t>
+              <a:t>27-10-2026</a:t>
             </a:fld>
             <a:endParaRPr lang="es-CL"/>
           </a:p>
@@ -4427,7 +4260,7 @@
           <a:p>
             <a:fld id="{524E32BF-339A-4FD7-AF2D-884DBB49ECE9}" type="slidenum">
               <a:rPr lang="es-CL" smtClean="0"/>
-              <a:t>‹Nº›</a:t>
+              <a:t>‹#›</a:t>
             </a:fld>
             <a:endParaRPr lang="es-CL"/>
           </a:p>
@@ -4743,7 +4576,7 @@
     <p:bg>
       <p:bgPr>
         <a:blipFill dpi="0" rotWithShape="1">
-          <a:blip r:embed="rId2">
+          <a:blip r:embed="rId3">
             <a:lum/>
           </a:blip>
           <a:srcRect/>
@@ -4792,7 +4625,7 @@
           </a:prstGeom>
         </p:spPr>
         <p:txBody>
-          <a:bodyPr vert="horz" lIns="91440" tIns="45720" rIns="91440" bIns="45720" rtlCol="0" anchor="b" wrap="square">
+          <a:bodyPr vert="horz" wrap="square" lIns="91440" tIns="45720" rIns="91440" bIns="45720" rtlCol="0" anchor="b">
             <a:noAutofit/>
           </a:bodyPr>
           <a:lstStyle>
@@ -5087,7 +4920,7 @@
                   <a:srgbClr val="FFFFFF"/>
                 </a:solidFill>
               </a:rPr>
-              <a:t xml:space="preserve">Modelamiento predictivo integrado · Evaluación Sumativa 3</a:t>
+              <a:t>Modelamiento predictivo integrado · Evaluación Sumativa 3</a:t>
             </a:r>
           </a:p>
           <a:p>
@@ -5102,7 +4935,7 @@
                   <a:srgbClr val="FFFFFF"/>
                 </a:solidFill>
               </a:rPr>
-              <a:t xml:space="preserve">María Fassler Neumann · Sebastian Antunez Noguera · Grupo 4</a:t>
+              <a:t>María Fassler Neumann · Sebastian Antunez Noguera · Grupo 4</a:t>
             </a:r>
           </a:p>
           <a:p>
@@ -5117,7 +4950,7 @@
                   <a:srgbClr val="FFFFFF"/>
                 </a:solidFill>
               </a:rPr>
-              <a:t xml:space="preserve">MCDI501 Estadística Computacional para la Toma de Decisiones</a:t>
+              <a:t>MCDI501 Estadística Computacional para la Toma de Decisiones</a:t>
             </a:r>
           </a:p>
         </p:txBody>
@@ -5325,7 +5158,7 @@
                   <a:srgbClr val="FFFFFF"/>
                 </a:solidFill>
               </a:rPr>
-              <a:t xml:space="preserve">Docente: Jean Paul Maidana · 28 de octubre de 2026</a:t>
+              <a:t>Docente: Jean Paul Maidana · 28 de octubre de 2026</a:t>
             </a:r>
           </a:p>
         </p:txBody>
@@ -5345,7 +5178,7 @@
           <p:nvPr/>
         </p:nvPicPr>
         <p:blipFill>
-          <a:blip r:embed="rId3">
+          <a:blip r:embed="rId4">
             <a:extLst>
               <a:ext uri="{28A0092B-C50C-407E-A947-70E740481C1C}">
                 <a14:useLocalDpi xmlns:a14="http://schemas.microsoft.com/office/drawing/2010/main" val="0"/>
@@ -5696,15 +5529,45 @@
         <a:graphic>
           <a:graphicData uri="http://schemas.openxmlformats.org/drawingml/2006/table">
             <a:tbl>
-              <a:tblPr firstRow="0" bandRow="0">
+              <a:tblPr>
                 <a:tableStyleId>{2D5ABB26-0587-4C30-8999-92F81FD0307C}</a:tableStyleId>
               </a:tblPr>
               <a:tblGrid>
-                <a:gridCol w="2490536"/>
-                <a:gridCol w="974557"/>
-                <a:gridCol w="974557"/>
-                <a:gridCol w="866273"/>
-                <a:gridCol w="866273"/>
+                <a:gridCol w="2490536">
+                  <a:extLst>
+                    <a:ext uri="{9D8B030D-6E8A-4147-A177-3AD203B41FA5}">
+                      <a16:colId xmlns:a16="http://schemas.microsoft.com/office/drawing/2014/main" val="20000"/>
+                    </a:ext>
+                  </a:extLst>
+                </a:gridCol>
+                <a:gridCol w="974557">
+                  <a:extLst>
+                    <a:ext uri="{9D8B030D-6E8A-4147-A177-3AD203B41FA5}">
+                      <a16:colId xmlns:a16="http://schemas.microsoft.com/office/drawing/2014/main" val="20001"/>
+                    </a:ext>
+                  </a:extLst>
+                </a:gridCol>
+                <a:gridCol w="974557">
+                  <a:extLst>
+                    <a:ext uri="{9D8B030D-6E8A-4147-A177-3AD203B41FA5}">
+                      <a16:colId xmlns:a16="http://schemas.microsoft.com/office/drawing/2014/main" val="20002"/>
+                    </a:ext>
+                  </a:extLst>
+                </a:gridCol>
+                <a:gridCol w="866273">
+                  <a:extLst>
+                    <a:ext uri="{9D8B030D-6E8A-4147-A177-3AD203B41FA5}">
+                      <a16:colId xmlns:a16="http://schemas.microsoft.com/office/drawing/2014/main" val="20003"/>
+                    </a:ext>
+                  </a:extLst>
+                </a:gridCol>
+                <a:gridCol w="866273">
+                  <a:extLst>
+                    <a:ext uri="{9D8B030D-6E8A-4147-A177-3AD203B41FA5}">
+                      <a16:colId xmlns:a16="http://schemas.microsoft.com/office/drawing/2014/main" val="20004"/>
+                    </a:ext>
+                  </a:extLst>
+                </a:gridCol>
               </a:tblGrid>
               <a:tr h="329184">
                 <a:tc>
@@ -5723,11 +5586,11 @@
                             <a:srgbClr val="FFFFFF"/>
                           </a:solidFill>
                         </a:rPr>
-                        <a:t xml:space="preserve">Conjunto de prueba</a:t>
+                        <a:t>Conjunto de prueba</a:t>
                       </a:r>
                     </a:p>
                   </a:txBody>
-                  <a:tcPr anchor="ctr" marL="64008" marR="64008" marT="18288" marB="18288">
+                  <a:tcPr marL="64008" marR="64008" marT="18288" marB="18288" anchor="ctr">
                     <a:solidFill>
                       <a:srgbClr val="20236D"/>
                     </a:solidFill>
@@ -5749,11 +5612,11 @@
                             <a:srgbClr val="FFFFFF"/>
                           </a:solidFill>
                         </a:rPr>
-                        <a:t xml:space="preserve">Exactitud</a:t>
+                        <a:t>Exactitud</a:t>
                       </a:r>
                     </a:p>
                   </a:txBody>
-                  <a:tcPr anchor="ctr" marL="64008" marR="64008" marT="18288" marB="18288">
+                  <a:tcPr marL="64008" marR="64008" marT="18288" marB="18288" anchor="ctr">
                     <a:solidFill>
                       <a:srgbClr val="20236D"/>
                     </a:solidFill>
@@ -5775,11 +5638,11 @@
                             <a:srgbClr val="FFFFFF"/>
                           </a:solidFill>
                         </a:rPr>
-                        <a:t xml:space="preserve">Sensib.</a:t>
+                        <a:t>Sensib.</a:t>
                       </a:r>
                     </a:p>
                   </a:txBody>
-                  <a:tcPr anchor="ctr" marL="64008" marR="64008" marT="18288" marB="18288">
+                  <a:tcPr marL="64008" marR="64008" marT="18288" marB="18288" anchor="ctr">
                     <a:solidFill>
                       <a:srgbClr val="20236D"/>
                     </a:solidFill>
@@ -5801,11 +5664,11 @@
                             <a:srgbClr val="FFFFFF"/>
                           </a:solidFill>
                         </a:rPr>
-                        <a:t xml:space="preserve">F1</a:t>
+                        <a:t>F1</a:t>
                       </a:r>
                     </a:p>
                   </a:txBody>
-                  <a:tcPr anchor="ctr" marL="64008" marR="64008" marT="18288" marB="18288">
+                  <a:tcPr marL="64008" marR="64008" marT="18288" marB="18288" anchor="ctr">
                     <a:solidFill>
                       <a:srgbClr val="20236D"/>
                     </a:solidFill>
@@ -5827,16 +5690,21 @@
                             <a:srgbClr val="FFFFFF"/>
                           </a:solidFill>
                         </a:rPr>
-                        <a:t xml:space="preserve">AUC</a:t>
+                        <a:t>AUC</a:t>
                       </a:r>
                     </a:p>
                   </a:txBody>
-                  <a:tcPr anchor="ctr" marL="64008" marR="64008" marT="18288" marB="18288">
+                  <a:tcPr marL="64008" marR="64008" marT="18288" marB="18288" anchor="ctr">
                     <a:solidFill>
                       <a:srgbClr val="20236D"/>
                     </a:solidFill>
                   </a:tcPr>
                 </a:tc>
+                <a:extLst>
+                  <a:ext uri="{0D108BD9-81ED-4DB2-BD59-A6C34878D82A}">
+                    <a16:rowId xmlns:a16="http://schemas.microsoft.com/office/drawing/2014/main" val="10000"/>
+                  </a:ext>
+                </a:extLst>
               </a:tr>
               <a:tr h="292608">
                 <a:tc>
@@ -5858,11 +5726,11 @@
                             </a:schemeClr>
                           </a:solidFill>
                         </a:rPr>
-                        <a:t xml:space="preserve">Línea base (siempre «alto»)</a:t>
+                        <a:t>Línea base (siempre «alto»)</a:t>
                       </a:r>
                     </a:p>
                   </a:txBody>
-                  <a:tcPr anchor="ctr" marL="64008" marR="64008" marT="18288" marB="18288">
+                  <a:tcPr marL="64008" marR="64008" marT="18288" marB="18288" anchor="ctr">
                     <a:lnB w="9525" cap="flat">
                       <a:solidFill>
                         <a:srgbClr val="C9CCDB"/>
@@ -5892,11 +5760,11 @@
                             </a:schemeClr>
                           </a:solidFill>
                         </a:rPr>
-                        <a:t xml:space="preserve">0,549</a:t>
+                        <a:t>0,549</a:t>
                       </a:r>
                     </a:p>
                   </a:txBody>
-                  <a:tcPr anchor="ctr" marL="64008" marR="64008" marT="18288" marB="18288">
+                  <a:tcPr marL="64008" marR="64008" marT="18288" marB="18288" anchor="ctr">
                     <a:lnB w="9525" cap="flat">
                       <a:solidFill>
                         <a:srgbClr val="C9CCDB"/>
@@ -5926,11 +5794,11 @@
                             </a:schemeClr>
                           </a:solidFill>
                         </a:rPr>
-                        <a:t xml:space="preserve">1,000</a:t>
+                        <a:t>1,000</a:t>
                       </a:r>
                     </a:p>
                   </a:txBody>
-                  <a:tcPr anchor="ctr" marL="64008" marR="64008" marT="18288" marB="18288">
+                  <a:tcPr marL="64008" marR="64008" marT="18288" marB="18288" anchor="ctr">
                     <a:lnB w="9525" cap="flat">
                       <a:solidFill>
                         <a:srgbClr val="C9CCDB"/>
@@ -5960,11 +5828,11 @@
                             </a:schemeClr>
                           </a:solidFill>
                         </a:rPr>
-                        <a:t xml:space="preserve">0,709</a:t>
+                        <a:t>0,709</a:t>
                       </a:r>
                     </a:p>
                   </a:txBody>
-                  <a:tcPr anchor="ctr" marL="64008" marR="64008" marT="18288" marB="18288">
+                  <a:tcPr marL="64008" marR="64008" marT="18288" marB="18288" anchor="ctr">
                     <a:lnB w="9525" cap="flat">
                       <a:solidFill>
                         <a:srgbClr val="C9CCDB"/>
@@ -5994,11 +5862,11 @@
                             </a:schemeClr>
                           </a:solidFill>
                         </a:rPr>
-                        <a:t xml:space="preserve">0,500</a:t>
+                        <a:t>0,500</a:t>
                       </a:r>
                     </a:p>
                   </a:txBody>
-                  <a:tcPr anchor="ctr" marL="64008" marR="64008" marT="18288" marB="18288">
+                  <a:tcPr marL="64008" marR="64008" marT="18288" marB="18288" anchor="ctr">
                     <a:lnB w="9525" cap="flat">
                       <a:solidFill>
                         <a:srgbClr val="C9CCDB"/>
@@ -6009,6 +5877,11 @@
                     </a:solidFill>
                   </a:tcPr>
                 </a:tc>
+                <a:extLst>
+                  <a:ext uri="{0D108BD9-81ED-4DB2-BD59-A6C34878D82A}">
+                    <a16:rowId xmlns:a16="http://schemas.microsoft.com/office/drawing/2014/main" val="10001"/>
+                  </a:ext>
+                </a:extLst>
               </a:tr>
               <a:tr h="292608">
                 <a:tc>
@@ -6030,11 +5903,20 @@
                             </a:schemeClr>
                           </a:solidFill>
                         </a:rPr>
-                        <a:t xml:space="preserve">M1, umbral 0,50</a:t>
+                        <a:t>M1, umbral 0,50</a:t>
                       </a:r>
                     </a:p>
                   </a:txBody>
-                  <a:tcPr anchor="ctr" marL="64008" marR="64008" marT="18288" marB="18288">
+                  <a:tcPr marL="64008" marR="64008" marT="18288" marB="18288" anchor="ctr">
+                    <a:lnT w="9525" cap="flat" cmpd="sng" algn="ctr">
+                      <a:solidFill>
+                        <a:srgbClr val="C9CCDB"/>
+                      </a:solidFill>
+                      <a:prstDash val="solid"/>
+                      <a:round/>
+                      <a:headEnd type="none" w="med" len="med"/>
+                      <a:tailEnd type="none" w="med" len="med"/>
+                    </a:lnT>
                     <a:lnB w="9525" cap="flat">
                       <a:solidFill>
                         <a:srgbClr val="C9CCDB"/>
@@ -6064,11 +5946,20 @@
                             </a:schemeClr>
                           </a:solidFill>
                         </a:rPr>
-                        <a:t xml:space="preserve">0,678</a:t>
+                        <a:t>0,678</a:t>
                       </a:r>
                     </a:p>
                   </a:txBody>
-                  <a:tcPr anchor="ctr" marL="64008" marR="64008" marT="18288" marB="18288">
+                  <a:tcPr marL="64008" marR="64008" marT="18288" marB="18288" anchor="ctr">
+                    <a:lnT w="9525" cap="flat" cmpd="sng" algn="ctr">
+                      <a:solidFill>
+                        <a:srgbClr val="C9CCDB"/>
+                      </a:solidFill>
+                      <a:prstDash val="solid"/>
+                      <a:round/>
+                      <a:headEnd type="none" w="med" len="med"/>
+                      <a:tailEnd type="none" w="med" len="med"/>
+                    </a:lnT>
                     <a:lnB w="9525" cap="flat">
                       <a:solidFill>
                         <a:srgbClr val="C9CCDB"/>
@@ -6098,11 +5989,20 @@
                             </a:schemeClr>
                           </a:solidFill>
                         </a:rPr>
-                        <a:t xml:space="preserve">0,754</a:t>
+                        <a:t>0,754</a:t>
                       </a:r>
                     </a:p>
                   </a:txBody>
-                  <a:tcPr anchor="ctr" marL="64008" marR="64008" marT="18288" marB="18288">
+                  <a:tcPr marL="64008" marR="64008" marT="18288" marB="18288" anchor="ctr">
+                    <a:lnT w="9525" cap="flat" cmpd="sng" algn="ctr">
+                      <a:solidFill>
+                        <a:srgbClr val="C9CCDB"/>
+                      </a:solidFill>
+                      <a:prstDash val="solid"/>
+                      <a:round/>
+                      <a:headEnd type="none" w="med" len="med"/>
+                      <a:tailEnd type="none" w="med" len="med"/>
+                    </a:lnT>
                     <a:lnB w="9525" cap="flat">
                       <a:solidFill>
                         <a:srgbClr val="C9CCDB"/>
@@ -6132,11 +6032,20 @@
                             </a:schemeClr>
                           </a:solidFill>
                         </a:rPr>
-                        <a:t xml:space="preserve">0,720</a:t>
+                        <a:t>0,720</a:t>
                       </a:r>
                     </a:p>
                   </a:txBody>
-                  <a:tcPr anchor="ctr" marL="64008" marR="64008" marT="18288" marB="18288">
+                  <a:tcPr marL="64008" marR="64008" marT="18288" marB="18288" anchor="ctr">
+                    <a:lnT w="9525" cap="flat" cmpd="sng" algn="ctr">
+                      <a:solidFill>
+                        <a:srgbClr val="C9CCDB"/>
+                      </a:solidFill>
+                      <a:prstDash val="solid"/>
+                      <a:round/>
+                      <a:headEnd type="none" w="med" len="med"/>
+                      <a:tailEnd type="none" w="med" len="med"/>
+                    </a:lnT>
                     <a:lnB w="9525" cap="flat">
                       <a:solidFill>
                         <a:srgbClr val="C9CCDB"/>
@@ -6166,11 +6075,20 @@
                             </a:schemeClr>
                           </a:solidFill>
                         </a:rPr>
-                        <a:t xml:space="preserve">0,730</a:t>
+                        <a:t>0,730</a:t>
                       </a:r>
                     </a:p>
                   </a:txBody>
-                  <a:tcPr anchor="ctr" marL="64008" marR="64008" marT="18288" marB="18288">
+                  <a:tcPr marL="64008" marR="64008" marT="18288" marB="18288" anchor="ctr">
+                    <a:lnT w="9525" cap="flat" cmpd="sng" algn="ctr">
+                      <a:solidFill>
+                        <a:srgbClr val="C9CCDB"/>
+                      </a:solidFill>
+                      <a:prstDash val="solid"/>
+                      <a:round/>
+                      <a:headEnd type="none" w="med" len="med"/>
+                      <a:tailEnd type="none" w="med" len="med"/>
+                    </a:lnT>
                     <a:lnB w="9525" cap="flat">
                       <a:solidFill>
                         <a:srgbClr val="C9CCDB"/>
@@ -6181,6 +6099,11 @@
                     </a:solidFill>
                   </a:tcPr>
                 </a:tc>
+                <a:extLst>
+                  <a:ext uri="{0D108BD9-81ED-4DB2-BD59-A6C34878D82A}">
+                    <a16:rowId xmlns:a16="http://schemas.microsoft.com/office/drawing/2014/main" val="10002"/>
+                  </a:ext>
+                </a:extLst>
               </a:tr>
               <a:tr h="292608">
                 <a:tc>
@@ -6202,11 +6125,20 @@
                             </a:schemeClr>
                           </a:solidFill>
                         </a:rPr>
-                        <a:t xml:space="preserve">M1 con ponderación de clase</a:t>
+                        <a:t>M1 con ponderación de clase</a:t>
                       </a:r>
                     </a:p>
                   </a:txBody>
-                  <a:tcPr anchor="ctr" marL="64008" marR="64008" marT="18288" marB="18288">
+                  <a:tcPr marL="64008" marR="64008" marT="18288" marB="18288" anchor="ctr">
+                    <a:lnT w="9525" cap="flat" cmpd="sng" algn="ctr">
+                      <a:solidFill>
+                        <a:srgbClr val="C9CCDB"/>
+                      </a:solidFill>
+                      <a:prstDash val="solid"/>
+                      <a:round/>
+                      <a:headEnd type="none" w="med" len="med"/>
+                      <a:tailEnd type="none" w="med" len="med"/>
+                    </a:lnT>
                     <a:lnB w="9525" cap="flat">
                       <a:solidFill>
                         <a:srgbClr val="C9CCDB"/>
@@ -6236,11 +6168,20 @@
                             </a:schemeClr>
                           </a:solidFill>
                         </a:rPr>
-                        <a:t xml:space="preserve">0,664</a:t>
+                        <a:t>0,664</a:t>
                       </a:r>
                     </a:p>
                   </a:txBody>
-                  <a:tcPr anchor="ctr" marL="64008" marR="64008" marT="18288" marB="18288">
+                  <a:tcPr marL="64008" marR="64008" marT="18288" marB="18288" anchor="ctr">
+                    <a:lnT w="9525" cap="flat" cmpd="sng" algn="ctr">
+                      <a:solidFill>
+                        <a:srgbClr val="C9CCDB"/>
+                      </a:solidFill>
+                      <a:prstDash val="solid"/>
+                      <a:round/>
+                      <a:headEnd type="none" w="med" len="med"/>
+                      <a:tailEnd type="none" w="med" len="med"/>
+                    </a:lnT>
                     <a:lnB w="9525" cap="flat">
                       <a:solidFill>
                         <a:srgbClr val="C9CCDB"/>
@@ -6270,11 +6211,20 @@
                             </a:schemeClr>
                           </a:solidFill>
                         </a:rPr>
-                        <a:t xml:space="preserve">0,674</a:t>
+                        <a:t>0,674</a:t>
                       </a:r>
                     </a:p>
                   </a:txBody>
-                  <a:tcPr anchor="ctr" marL="64008" marR="64008" marT="18288" marB="18288">
+                  <a:tcPr marL="64008" marR="64008" marT="18288" marB="18288" anchor="ctr">
+                    <a:lnT w="9525" cap="flat" cmpd="sng" algn="ctr">
+                      <a:solidFill>
+                        <a:srgbClr val="C9CCDB"/>
+                      </a:solidFill>
+                      <a:prstDash val="solid"/>
+                      <a:round/>
+                      <a:headEnd type="none" w="med" len="med"/>
+                      <a:tailEnd type="none" w="med" len="med"/>
+                    </a:lnT>
                     <a:lnB w="9525" cap="flat">
                       <a:solidFill>
                         <a:srgbClr val="C9CCDB"/>
@@ -6304,11 +6254,20 @@
                             </a:schemeClr>
                           </a:solidFill>
                         </a:rPr>
-                        <a:t xml:space="preserve">0,688</a:t>
+                        <a:t>0,688</a:t>
                       </a:r>
                     </a:p>
                   </a:txBody>
-                  <a:tcPr anchor="ctr" marL="64008" marR="64008" marT="18288" marB="18288">
+                  <a:tcPr marL="64008" marR="64008" marT="18288" marB="18288" anchor="ctr">
+                    <a:lnT w="9525" cap="flat" cmpd="sng" algn="ctr">
+                      <a:solidFill>
+                        <a:srgbClr val="C9CCDB"/>
+                      </a:solidFill>
+                      <a:prstDash val="solid"/>
+                      <a:round/>
+                      <a:headEnd type="none" w="med" len="med"/>
+                      <a:tailEnd type="none" w="med" len="med"/>
+                    </a:lnT>
                     <a:lnB w="9525" cap="flat">
                       <a:solidFill>
                         <a:srgbClr val="C9CCDB"/>
@@ -6338,11 +6297,20 @@
                             </a:schemeClr>
                           </a:solidFill>
                         </a:rPr>
-                        <a:t xml:space="preserve">0,730</a:t>
+                        <a:t>0,730</a:t>
                       </a:r>
                     </a:p>
                   </a:txBody>
-                  <a:tcPr anchor="ctr" marL="64008" marR="64008" marT="18288" marB="18288">
+                  <a:tcPr marL="64008" marR="64008" marT="18288" marB="18288" anchor="ctr">
+                    <a:lnT w="9525" cap="flat" cmpd="sng" algn="ctr">
+                      <a:solidFill>
+                        <a:srgbClr val="C9CCDB"/>
+                      </a:solidFill>
+                      <a:prstDash val="solid"/>
+                      <a:round/>
+                      <a:headEnd type="none" w="med" len="med"/>
+                      <a:tailEnd type="none" w="med" len="med"/>
+                    </a:lnT>
                     <a:lnB w="9525" cap="flat">
                       <a:solidFill>
                         <a:srgbClr val="C9CCDB"/>
@@ -6353,6 +6321,11 @@
                     </a:solidFill>
                   </a:tcPr>
                 </a:tc>
+                <a:extLst>
+                  <a:ext uri="{0D108BD9-81ED-4DB2-BD59-A6C34878D82A}">
+                    <a16:rowId xmlns:a16="http://schemas.microsoft.com/office/drawing/2014/main" val="10003"/>
+                  </a:ext>
+                </a:extLst>
               </a:tr>
               <a:tr h="292608">
                 <a:tc>
@@ -6374,11 +6347,20 @@
                             </a:schemeClr>
                           </a:solidFill>
                         </a:rPr>
-                        <a:t xml:space="preserve">M1, umbral 0,418</a:t>
+                        <a:t>M1, umbral 0,418</a:t>
                       </a:r>
                     </a:p>
                   </a:txBody>
-                  <a:tcPr anchor="ctr" marL="64008" marR="64008" marT="18288" marB="18288">
+                  <a:tcPr marL="64008" marR="64008" marT="18288" marB="18288" anchor="ctr">
+                    <a:lnT w="9525" cap="flat" cmpd="sng" algn="ctr">
+                      <a:solidFill>
+                        <a:srgbClr val="C9CCDB"/>
+                      </a:solidFill>
+                      <a:prstDash val="solid"/>
+                      <a:round/>
+                      <a:headEnd type="none" w="med" len="med"/>
+                      <a:tailEnd type="none" w="med" len="med"/>
+                    </a:lnT>
                     <a:lnB w="9525" cap="flat">
                       <a:solidFill>
                         <a:srgbClr val="C9CCDB"/>
@@ -6408,11 +6390,20 @@
                             </a:schemeClr>
                           </a:solidFill>
                         </a:rPr>
-                        <a:t xml:space="preserve">0,672</a:t>
+                        <a:t>0,672</a:t>
                       </a:r>
                     </a:p>
                   </a:txBody>
-                  <a:tcPr anchor="ctr" marL="64008" marR="64008" marT="18288" marB="18288">
+                  <a:tcPr marL="64008" marR="64008" marT="18288" marB="18288" anchor="ctr">
+                    <a:lnT w="9525" cap="flat" cmpd="sng" algn="ctr">
+                      <a:solidFill>
+                        <a:srgbClr val="C9CCDB"/>
+                      </a:solidFill>
+                      <a:prstDash val="solid"/>
+                      <a:round/>
+                      <a:headEnd type="none" w="med" len="med"/>
+                      <a:tailEnd type="none" w="med" len="med"/>
+                    </a:lnT>
                     <a:lnB w="9525" cap="flat">
                       <a:solidFill>
                         <a:srgbClr val="C9CCDB"/>
@@ -6442,11 +6433,20 @@
                             </a:schemeClr>
                           </a:solidFill>
                         </a:rPr>
-                        <a:t xml:space="preserve">0,850</a:t>
+                        <a:t>0,850</a:t>
                       </a:r>
                     </a:p>
                   </a:txBody>
-                  <a:tcPr anchor="ctr" marL="64008" marR="64008" marT="18288" marB="18288">
+                  <a:tcPr marL="64008" marR="64008" marT="18288" marB="18288" anchor="ctr">
+                    <a:lnT w="9525" cap="flat" cmpd="sng" algn="ctr">
+                      <a:solidFill>
+                        <a:srgbClr val="C9CCDB"/>
+                      </a:solidFill>
+                      <a:prstDash val="solid"/>
+                      <a:round/>
+                      <a:headEnd type="none" w="med" len="med"/>
+                      <a:tailEnd type="none" w="med" len="med"/>
+                    </a:lnT>
                     <a:lnB w="9525" cap="flat">
                       <a:solidFill>
                         <a:srgbClr val="C9CCDB"/>
@@ -6476,11 +6476,20 @@
                             </a:schemeClr>
                           </a:solidFill>
                         </a:rPr>
-                        <a:t xml:space="preserve">0,740</a:t>
+                        <a:t>0,740</a:t>
                       </a:r>
                     </a:p>
                   </a:txBody>
-                  <a:tcPr anchor="ctr" marL="64008" marR="64008" marT="18288" marB="18288">
+                  <a:tcPr marL="64008" marR="64008" marT="18288" marB="18288" anchor="ctr">
+                    <a:lnT w="9525" cap="flat" cmpd="sng" algn="ctr">
+                      <a:solidFill>
+                        <a:srgbClr val="C9CCDB"/>
+                      </a:solidFill>
+                      <a:prstDash val="solid"/>
+                      <a:round/>
+                      <a:headEnd type="none" w="med" len="med"/>
+                      <a:tailEnd type="none" w="med" len="med"/>
+                    </a:lnT>
                     <a:lnB w="9525" cap="flat">
                       <a:solidFill>
                         <a:srgbClr val="C9CCDB"/>
@@ -6510,11 +6519,20 @@
                             </a:schemeClr>
                           </a:solidFill>
                         </a:rPr>
-                        <a:t xml:space="preserve">0,730</a:t>
+                        <a:t>0,730</a:t>
                       </a:r>
                     </a:p>
                   </a:txBody>
-                  <a:tcPr anchor="ctr" marL="64008" marR="64008" marT="18288" marB="18288">
+                  <a:tcPr marL="64008" marR="64008" marT="18288" marB="18288" anchor="ctr">
+                    <a:lnT w="9525" cap="flat" cmpd="sng" algn="ctr">
+                      <a:solidFill>
+                        <a:srgbClr val="C9CCDB"/>
+                      </a:solidFill>
+                      <a:prstDash val="solid"/>
+                      <a:round/>
+                      <a:headEnd type="none" w="med" len="med"/>
+                      <a:tailEnd type="none" w="med" len="med"/>
+                    </a:lnT>
                     <a:lnB w="9525" cap="flat">
                       <a:solidFill>
                         <a:srgbClr val="C9CCDB"/>
@@ -6525,6 +6543,11 @@
                     </a:solidFill>
                   </a:tcPr>
                 </a:tc>
+                <a:extLst>
+                  <a:ext uri="{0D108BD9-81ED-4DB2-BD59-A6C34878D82A}">
+                    <a16:rowId xmlns:a16="http://schemas.microsoft.com/office/drawing/2014/main" val="10004"/>
+                  </a:ext>
+                </a:extLst>
               </a:tr>
             </a:tbl>
           </a:graphicData>
@@ -6563,7 +6586,7 @@
                   <a:srgbClr val="20236D"/>
                 </a:solidFill>
               </a:rPr>
-              <a:t xml:space="preserve">Tres lecturas</a:t>
+              <a:t>Tres lecturas</a:t>
             </a:r>
           </a:p>
           <a:p>
@@ -6583,7 +6606,7 @@
                   </a:schemeClr>
                 </a:solidFill>
               </a:rPr>
-              <a:t xml:space="preserve">Sin línea base nada significa: en un conjunto 55/45, acertar la mitad es gratis. La ganancia real es el AUC, de 0,500 a 0,730.</a:t>
+              <a:t>Sin línea base nada significa: en un conjunto 55/45, acertar la mitad es gratis. La ganancia real es el AUC, de 0,500 a 0,730.</a:t>
             </a:r>
           </a:p>
           <a:p>
@@ -6603,7 +6626,7 @@
                   </a:schemeClr>
                 </a:solidFill>
               </a:rPr>
-              <a:t xml:space="preserve">La ponderación de clase </a:t>
+              <a:t>La ponderación de clase </a:t>
             </a:r>
             <a:r>
               <a:rPr lang="es-CL" sz="1250" b="1" i="0" dirty="0">
@@ -6614,7 +6637,7 @@
                   </a:schemeClr>
                 </a:solidFill>
               </a:rPr>
-              <a:t xml:space="preserve">baja</a:t>
+              <a:t>baja</a:t>
             </a:r>
             <a:r>
               <a:rPr lang="es-CL" sz="1250" b="0" i="0" dirty="0">
@@ -6625,7 +6648,7 @@
                   </a:schemeClr>
                 </a:solidFill>
               </a:rPr>
-              <a:t xml:space="preserve"> la sensibilidad ocho puntos, porque aquí la clase positiva es la mayoritaria.</a:t>
+              <a:t> la sensibilidad ocho puntos, porque aquí la clase positiva es la mayoritaria.</a:t>
             </a:r>
           </a:p>
           <a:p>
@@ -6645,7 +6668,7 @@
                   </a:schemeClr>
                 </a:solidFill>
               </a:rPr>
-              <a:t xml:space="preserve">Bajar el umbral a 0,418 la sube a 0,850 y da el mejor F1 de todas las configuraciones.</a:t>
+              <a:t>Bajar el umbral a 0,418 la sube a 0,850 y da el mejor F1 de todas las configuraciones.</a:t>
             </a:r>
           </a:p>
         </p:txBody>
@@ -6683,7 +6706,7 @@
                   <a:srgbClr val="20236D"/>
                 </a:solidFill>
               </a:rPr>
-              <a:t xml:space="preserve">Por qué se invierte</a:t>
+              <a:t>Por qué se invierte</a:t>
             </a:r>
           </a:p>
           <a:p>
@@ -6701,7 +6724,7 @@
                   </a:schemeClr>
                 </a:solidFill>
               </a:rPr>
-              <a:t xml:space="preserve">La ponderación equilibrada rebaja el peso de la clase mayoritaria. El recetario «ponderar sube el recall» supone que la positiva es la minoritaria.</a:t>
+              <a:t>La ponderación equilibrada rebaja el peso de la clase mayoritaria. El recetario «ponderar sube el recall» supone que la positiva es la minoritaria.</a:t>
             </a:r>
           </a:p>
           <a:p>
@@ -6719,7 +6742,7 @@
                   </a:schemeClr>
                 </a:solidFill>
               </a:rPr>
-              <a:t xml:space="preserve">Aquí la positiva es «abandono alto», con </a:t>
+              <a:t>Aquí la positiva es «abandono alto», con </a:t>
             </a:r>
             <a:r>
               <a:rPr lang="es-CL" sz="1250" b="1" i="0" dirty="0">
@@ -6730,7 +6753,7 @@
                   </a:schemeClr>
                 </a:solidFill>
               </a:rPr>
-              <a:t xml:space="preserve">54,9 %</a:t>
+              <a:t>54,9 %</a:t>
             </a:r>
             <a:r>
               <a:rPr lang="es-CL" sz="1250" b="0" i="0" dirty="0">
@@ -6741,7 +6764,7 @@
                   </a:schemeClr>
                 </a:solidFill>
               </a:rPr>
-              <a:t xml:space="preserve">. Los pesos quedan en 0,910 y 1,110 y el efecto se da vuelta.</a:t>
+              <a:t>. Los pesos quedan en 0,910 y 1,110 y el efecto se da vuelta.</a:t>
             </a:r>
           </a:p>
           <a:p>
@@ -6759,7 +6782,7 @@
                   </a:schemeClr>
                 </a:solidFill>
               </a:rPr>
-              <a:t xml:space="preserve">El AUC no se mueve en ninguna configuración: ninguna palanca cambia el orden de las probabilidades, solo el punto de corte.</a:t>
+              <a:t>El AUC no se mueve en ninguna configuración: ninguna palanca cambia el orden de las probabilidades, solo el punto de corte.</a:t>
             </a:r>
           </a:p>
         </p:txBody>
@@ -6800,7 +6823,7 @@
                   </a:schemeClr>
                 </a:solidFill>
               </a:rPr>
-              <a:t xml:space="preserve">Los tres modelos rinden casi igual en prueba, con AUC de 0,712 a 0,733: la decisión del umbral pesa más que la elección entre ellos.</a:t>
+              <a:t>Los tres modelos rinden casi igual en prueba, con AUC de 0,712 a 0,733: la decisión del umbral pesa más que la elección entre ellos.</a:t>
             </a:r>
           </a:p>
         </p:txBody>
@@ -7130,7 +7153,7 @@
           <p:nvPr/>
         </p:nvPicPr>
         <p:blipFill>
-          <a:blip r:embed="rId2"/>
+          <a:blip r:embed="rId4"/>
           <a:stretch>
             <a:fillRect/>
           </a:stretch>
@@ -7178,7 +7201,7 @@
                   <a:srgbClr val="20236D"/>
                 </a:solidFill>
               </a:rPr>
-              <a:t xml:space="preserve">Remuestreando observaciones</a:t>
+              <a:t>Remuestreando observaciones</a:t>
             </a:r>
           </a:p>
           <a:p>
@@ -7196,7 +7219,7 @@
                   </a:schemeClr>
                 </a:solidFill>
               </a:rPr>
-              <a:t xml:space="preserve">Los intervalos reproducen los clásicos: razón 1,00 a 1,12. La precisión declarada es correcta.</a:t>
+              <a:t>Los intervalos reproducen los clásicos: razón 1,00 a 1,12. La precisión declarada es correcta.</a:t>
             </a:r>
           </a:p>
         </p:txBody>
@@ -7234,7 +7257,7 @@
                   <a:srgbClr val="20236D"/>
                 </a:solidFill>
               </a:rPr>
-              <a:t xml:space="preserve">Remuestreando instituciones</a:t>
+              <a:t>Remuestreando instituciones</a:t>
             </a:r>
           </a:p>
           <a:p>
@@ -7252,7 +7275,7 @@
                   </a:schemeClr>
                 </a:solidFill>
               </a:rPr>
-              <a:t xml:space="preserve">Se ensanchan entre </a:t>
+              <a:t>Se ensanchan entre </a:t>
             </a:r>
             <a:r>
               <a:rPr lang="es-CL" sz="1250" b="1" i="0" dirty="0">
@@ -7263,7 +7286,7 @@
                   </a:schemeClr>
                 </a:solidFill>
               </a:rPr>
-              <a:t xml:space="preserve">1,62 y 3,01 veces</a:t>
+              <a:t>1,62 y 3,01 veces</a:t>
             </a:r>
             <a:r>
               <a:rPr lang="es-CL" sz="1250" b="0" i="0" dirty="0">
@@ -7274,7 +7297,7 @@
                   </a:schemeClr>
                 </a:solidFill>
               </a:rPr>
-              <a:t xml:space="preserve">, y siete de veinte coeficientes pierden el signo.</a:t>
+              <a:t>, y siete de veinte coeficientes pierden el signo.</a:t>
             </a:r>
           </a:p>
         </p:txBody>
@@ -7610,14 +7633,38 @@
         <a:graphic>
           <a:graphicData uri="http://schemas.openxmlformats.org/drawingml/2006/table">
             <a:tbl>
-              <a:tblPr firstRow="0" bandRow="0">
+              <a:tblPr>
                 <a:tableStyleId>{2D5ABB26-0587-4C30-8999-92F81FD0307C}</a:tableStyleId>
               </a:tblPr>
               <a:tblGrid>
-                <a:gridCol w="2072640"/>
-                <a:gridCol w="731520"/>
-                <a:gridCol w="1097280"/>
-                <a:gridCol w="1584960"/>
+                <a:gridCol w="2072640">
+                  <a:extLst>
+                    <a:ext uri="{9D8B030D-6E8A-4147-A177-3AD203B41FA5}">
+                      <a16:colId xmlns:a16="http://schemas.microsoft.com/office/drawing/2014/main" val="20000"/>
+                    </a:ext>
+                  </a:extLst>
+                </a:gridCol>
+                <a:gridCol w="731520">
+                  <a:extLst>
+                    <a:ext uri="{9D8B030D-6E8A-4147-A177-3AD203B41FA5}">
+                      <a16:colId xmlns:a16="http://schemas.microsoft.com/office/drawing/2014/main" val="20001"/>
+                    </a:ext>
+                  </a:extLst>
+                </a:gridCol>
+                <a:gridCol w="1097280">
+                  <a:extLst>
+                    <a:ext uri="{9D8B030D-6E8A-4147-A177-3AD203B41FA5}">
+                      <a16:colId xmlns:a16="http://schemas.microsoft.com/office/drawing/2014/main" val="20002"/>
+                    </a:ext>
+                  </a:extLst>
+                </a:gridCol>
+                <a:gridCol w="1584960">
+                  <a:extLst>
+                    <a:ext uri="{9D8B030D-6E8A-4147-A177-3AD203B41FA5}">
+                      <a16:colId xmlns:a16="http://schemas.microsoft.com/office/drawing/2014/main" val="20003"/>
+                    </a:ext>
+                  </a:extLst>
+                </a:gridCol>
               </a:tblGrid>
               <a:tr h="329184">
                 <a:tc>
@@ -7636,11 +7683,11 @@
                             <a:srgbClr val="FFFFFF"/>
                           </a:solidFill>
                         </a:rPr>
-                        <a:t xml:space="preserve">Variable continua</a:t>
+                        <a:t>Variable continua</a:t>
                       </a:r>
                     </a:p>
                   </a:txBody>
-                  <a:tcPr anchor="ctr" marL="64008" marR="64008" marT="18288" marB="18288">
+                  <a:tcPr marL="64008" marR="64008" marT="18288" marB="18288" anchor="ctr">
                     <a:solidFill>
                       <a:srgbClr val="20236D"/>
                     </a:solidFill>
@@ -7662,11 +7709,11 @@
                             <a:srgbClr val="FFFFFF"/>
                           </a:solidFill>
                         </a:rPr>
-                        <a:t xml:space="preserve">VIF</a:t>
+                        <a:t>VIF</a:t>
                       </a:r>
                     </a:p>
                   </a:txBody>
-                  <a:tcPr anchor="ctr" marL="64008" marR="64008" marT="18288" marB="18288">
+                  <a:tcPr marL="64008" marR="64008" marT="18288" marB="18288" anchor="ctr">
                     <a:solidFill>
                       <a:srgbClr val="20236D"/>
                     </a:solidFill>
@@ -7688,11 +7735,11 @@
                             <a:srgbClr val="FFFFFF"/>
                           </a:solidFill>
                         </a:rPr>
-                        <a:t xml:space="preserve">Box-Tidwell</a:t>
+                        <a:t>Box-Tidwell</a:t>
                       </a:r>
                     </a:p>
                   </a:txBody>
-                  <a:tcPr anchor="ctr" marL="64008" marR="64008" marT="18288" marB="18288">
+                  <a:tcPr marL="64008" marR="64008" marT="18288" marB="18288" anchor="ctr">
                     <a:solidFill>
                       <a:srgbClr val="20236D"/>
                     </a:solidFill>
@@ -7714,16 +7761,21 @@
                             <a:srgbClr val="FFFFFF"/>
                           </a:solidFill>
                         </a:rPr>
-                        <a:t xml:space="preserve">Linealidad en el logit</a:t>
+                        <a:t>Linealidad en el logit</a:t>
                       </a:r>
                     </a:p>
                   </a:txBody>
-                  <a:tcPr anchor="ctr" marL="64008" marR="64008" marT="18288" marB="18288">
+                  <a:tcPr marL="64008" marR="64008" marT="18288" marB="18288" anchor="ctr">
                     <a:solidFill>
                       <a:srgbClr val="20236D"/>
                     </a:solidFill>
                   </a:tcPr>
                 </a:tc>
+                <a:extLst>
+                  <a:ext uri="{0D108BD9-81ED-4DB2-BD59-A6C34878D82A}">
+                    <a16:rowId xmlns:a16="http://schemas.microsoft.com/office/drawing/2014/main" val="10000"/>
+                  </a:ext>
+                </a:extLst>
               </a:tr>
               <a:tr h="292608">
                 <a:tc>
@@ -7745,11 +7797,11 @@
                             </a:schemeClr>
                           </a:solidFill>
                         </a:rPr>
-                        <a:t xml:space="preserve">carrera_acreditada</a:t>
+                        <a:t>carrera_acreditada</a:t>
                       </a:r>
                     </a:p>
                   </a:txBody>
-                  <a:tcPr anchor="ctr" marL="64008" marR="64008" marT="18288" marB="18288">
+                  <a:tcPr marL="64008" marR="64008" marT="18288" marB="18288" anchor="ctr">
                     <a:lnB w="9525" cap="flat">
                       <a:solidFill>
                         <a:srgbClr val="C9CCDB"/>
@@ -7779,11 +7831,11 @@
                             </a:schemeClr>
                           </a:solidFill>
                         </a:rPr>
-                        <a:t xml:space="preserve">1,21</a:t>
+                        <a:t>1,21</a:t>
                       </a:r>
                     </a:p>
                   </a:txBody>
-                  <a:tcPr anchor="ctr" marL="64008" marR="64008" marT="18288" marB="18288">
+                  <a:tcPr marL="64008" marR="64008" marT="18288" marB="18288" anchor="ctr">
                     <a:lnB w="9525" cap="flat">
                       <a:solidFill>
                         <a:srgbClr val="C9CCDB"/>
@@ -7813,11 +7865,11 @@
                             </a:schemeClr>
                           </a:solidFill>
                         </a:rPr>
-                        <a:t xml:space="preserve">&lt; 0,001</a:t>
+                        <a:t>&lt; 0,001</a:t>
                       </a:r>
                     </a:p>
                   </a:txBody>
-                  <a:tcPr anchor="ctr" marL="64008" marR="64008" marT="18288" marB="18288">
+                  <a:tcPr marL="64008" marR="64008" marT="18288" marB="18288" anchor="ctr">
                     <a:lnB w="9525" cap="flat">
                       <a:solidFill>
                         <a:srgbClr val="C9CCDB"/>
@@ -7847,11 +7899,11 @@
                             </a:schemeClr>
                           </a:solidFill>
                         </a:rPr>
-                        <a:t xml:space="preserve">No lineal</a:t>
+                        <a:t>No lineal</a:t>
                       </a:r>
                     </a:p>
                   </a:txBody>
-                  <a:tcPr anchor="ctr" marL="64008" marR="64008" marT="18288" marB="18288">
+                  <a:tcPr marL="64008" marR="64008" marT="18288" marB="18288" anchor="ctr">
                     <a:lnB w="9525" cap="flat">
                       <a:solidFill>
                         <a:srgbClr val="C9CCDB"/>
@@ -7862,6 +7914,11 @@
                     </a:solidFill>
                   </a:tcPr>
                 </a:tc>
+                <a:extLst>
+                  <a:ext uri="{0D108BD9-81ED-4DB2-BD59-A6C34878D82A}">
+                    <a16:rowId xmlns:a16="http://schemas.microsoft.com/office/drawing/2014/main" val="10001"/>
+                  </a:ext>
+                </a:extLst>
               </a:tr>
               <a:tr h="292608">
                 <a:tc>
@@ -7883,11 +7940,20 @@
                             </a:schemeClr>
                           </a:solidFill>
                         </a:rPr>
-                        <a:t xml:space="preserve">inst_acreditada</a:t>
+                        <a:t>inst_acreditada</a:t>
                       </a:r>
                     </a:p>
                   </a:txBody>
-                  <a:tcPr anchor="ctr" marL="64008" marR="64008" marT="18288" marB="18288">
+                  <a:tcPr marL="64008" marR="64008" marT="18288" marB="18288" anchor="ctr">
+                    <a:lnT w="9525" cap="flat" cmpd="sng" algn="ctr">
+                      <a:solidFill>
+                        <a:srgbClr val="C9CCDB"/>
+                      </a:solidFill>
+                      <a:prstDash val="solid"/>
+                      <a:round/>
+                      <a:headEnd type="none" w="med" len="med"/>
+                      <a:tailEnd type="none" w="med" len="med"/>
+                    </a:lnT>
                     <a:lnB w="9525" cap="flat">
                       <a:solidFill>
                         <a:srgbClr val="C9CCDB"/>
@@ -7917,11 +7983,20 @@
                             </a:schemeClr>
                           </a:solidFill>
                         </a:rPr>
-                        <a:t xml:space="preserve">1,13</a:t>
+                        <a:t>1,13</a:t>
                       </a:r>
                     </a:p>
                   </a:txBody>
-                  <a:tcPr anchor="ctr" marL="64008" marR="64008" marT="18288" marB="18288">
+                  <a:tcPr marL="64008" marR="64008" marT="18288" marB="18288" anchor="ctr">
+                    <a:lnT w="9525" cap="flat" cmpd="sng" algn="ctr">
+                      <a:solidFill>
+                        <a:srgbClr val="C9CCDB"/>
+                      </a:solidFill>
+                      <a:prstDash val="solid"/>
+                      <a:round/>
+                      <a:headEnd type="none" w="med" len="med"/>
+                      <a:tailEnd type="none" w="med" len="med"/>
+                    </a:lnT>
                     <a:lnB w="9525" cap="flat">
                       <a:solidFill>
                         <a:srgbClr val="C9CCDB"/>
@@ -7951,11 +8026,20 @@
                             </a:schemeClr>
                           </a:solidFill>
                         </a:rPr>
-                        <a:t xml:space="preserve">&lt; 0,001</a:t>
+                        <a:t>&lt; 0,001</a:t>
                       </a:r>
                     </a:p>
                   </a:txBody>
-                  <a:tcPr anchor="ctr" marL="64008" marR="64008" marT="18288" marB="18288">
+                  <a:tcPr marL="64008" marR="64008" marT="18288" marB="18288" anchor="ctr">
+                    <a:lnT w="9525" cap="flat" cmpd="sng" algn="ctr">
+                      <a:solidFill>
+                        <a:srgbClr val="C9CCDB"/>
+                      </a:solidFill>
+                      <a:prstDash val="solid"/>
+                      <a:round/>
+                      <a:headEnd type="none" w="med" len="med"/>
+                      <a:tailEnd type="none" w="med" len="med"/>
+                    </a:lnT>
                     <a:lnB w="9525" cap="flat">
                       <a:solidFill>
                         <a:srgbClr val="C9CCDB"/>
@@ -7985,11 +8069,20 @@
                             </a:schemeClr>
                           </a:solidFill>
                         </a:rPr>
-                        <a:t xml:space="preserve">No lineal</a:t>
+                        <a:t>No lineal</a:t>
                       </a:r>
                     </a:p>
                   </a:txBody>
-                  <a:tcPr anchor="ctr" marL="64008" marR="64008" marT="18288" marB="18288">
+                  <a:tcPr marL="64008" marR="64008" marT="18288" marB="18288" anchor="ctr">
+                    <a:lnT w="9525" cap="flat" cmpd="sng" algn="ctr">
+                      <a:solidFill>
+                        <a:srgbClr val="C9CCDB"/>
+                      </a:solidFill>
+                      <a:prstDash val="solid"/>
+                      <a:round/>
+                      <a:headEnd type="none" w="med" len="med"/>
+                      <a:tailEnd type="none" w="med" len="med"/>
+                    </a:lnT>
                     <a:lnB w="9525" cap="flat">
                       <a:solidFill>
                         <a:srgbClr val="C9CCDB"/>
@@ -8000,6 +8093,11 @@
                     </a:solidFill>
                   </a:tcPr>
                 </a:tc>
+                <a:extLst>
+                  <a:ext uri="{0D108BD9-81ED-4DB2-BD59-A6C34878D82A}">
+                    <a16:rowId xmlns:a16="http://schemas.microsoft.com/office/drawing/2014/main" val="10002"/>
+                  </a:ext>
+                </a:extLst>
               </a:tr>
               <a:tr h="292608">
                 <a:tc>
@@ -8021,11 +8119,20 @@
                             </a:schemeClr>
                           </a:solidFill>
                         </a:rPr>
-                        <a:t xml:space="preserve">log_matricula</a:t>
+                        <a:t>log_matricula</a:t>
                       </a:r>
                     </a:p>
                   </a:txBody>
-                  <a:tcPr anchor="ctr" marL="64008" marR="64008" marT="18288" marB="18288">
+                  <a:tcPr marL="64008" marR="64008" marT="18288" marB="18288" anchor="ctr">
+                    <a:lnT w="9525" cap="flat" cmpd="sng" algn="ctr">
+                      <a:solidFill>
+                        <a:srgbClr val="C9CCDB"/>
+                      </a:solidFill>
+                      <a:prstDash val="solid"/>
+                      <a:round/>
+                      <a:headEnd type="none" w="med" len="med"/>
+                      <a:tailEnd type="none" w="med" len="med"/>
+                    </a:lnT>
                     <a:lnB w="9525" cap="flat">
                       <a:solidFill>
                         <a:srgbClr val="C9CCDB"/>
@@ -8055,11 +8162,20 @@
                             </a:schemeClr>
                           </a:solidFill>
                         </a:rPr>
-                        <a:t xml:space="preserve">1,12</a:t>
+                        <a:t>1,12</a:t>
                       </a:r>
                     </a:p>
                   </a:txBody>
-                  <a:tcPr anchor="ctr" marL="64008" marR="64008" marT="18288" marB="18288">
+                  <a:tcPr marL="64008" marR="64008" marT="18288" marB="18288" anchor="ctr">
+                    <a:lnT w="9525" cap="flat" cmpd="sng" algn="ctr">
+                      <a:solidFill>
+                        <a:srgbClr val="C9CCDB"/>
+                      </a:solidFill>
+                      <a:prstDash val="solid"/>
+                      <a:round/>
+                      <a:headEnd type="none" w="med" len="med"/>
+                      <a:tailEnd type="none" w="med" len="med"/>
+                    </a:lnT>
                     <a:lnB w="9525" cap="flat">
                       <a:solidFill>
                         <a:srgbClr val="C9CCDB"/>
@@ -8089,11 +8205,20 @@
                             </a:schemeClr>
                           </a:solidFill>
                         </a:rPr>
-                        <a:t xml:space="preserve">0,369</a:t>
+                        <a:t>0,369</a:t>
                       </a:r>
                     </a:p>
                   </a:txBody>
-                  <a:tcPr anchor="ctr" marL="64008" marR="64008" marT="18288" marB="18288">
+                  <a:tcPr marL="64008" marR="64008" marT="18288" marB="18288" anchor="ctr">
+                    <a:lnT w="9525" cap="flat" cmpd="sng" algn="ctr">
+                      <a:solidFill>
+                        <a:srgbClr val="C9CCDB"/>
+                      </a:solidFill>
+                      <a:prstDash val="solid"/>
+                      <a:round/>
+                      <a:headEnd type="none" w="med" len="med"/>
+                      <a:tailEnd type="none" w="med" len="med"/>
+                    </a:lnT>
                     <a:lnB w="9525" cap="flat">
                       <a:solidFill>
                         <a:srgbClr val="C9CCDB"/>
@@ -8123,11 +8248,20 @@
                             </a:schemeClr>
                           </a:solidFill>
                         </a:rPr>
-                        <a:t xml:space="preserve">Lineal</a:t>
+                        <a:t>Lineal</a:t>
                       </a:r>
                     </a:p>
                   </a:txBody>
-                  <a:tcPr anchor="ctr" marL="64008" marR="64008" marT="18288" marB="18288">
+                  <a:tcPr marL="64008" marR="64008" marT="18288" marB="18288" anchor="ctr">
+                    <a:lnT w="9525" cap="flat" cmpd="sng" algn="ctr">
+                      <a:solidFill>
+                        <a:srgbClr val="C9CCDB"/>
+                      </a:solidFill>
+                      <a:prstDash val="solid"/>
+                      <a:round/>
+                      <a:headEnd type="none" w="med" len="med"/>
+                      <a:tailEnd type="none" w="med" len="med"/>
+                    </a:lnT>
                     <a:lnB w="9525" cap="flat">
                       <a:solidFill>
                         <a:srgbClr val="C9CCDB"/>
@@ -8138,6 +8272,11 @@
                     </a:solidFill>
                   </a:tcPr>
                 </a:tc>
+                <a:extLst>
+                  <a:ext uri="{0D108BD9-81ED-4DB2-BD59-A6C34878D82A}">
+                    <a16:rowId xmlns:a16="http://schemas.microsoft.com/office/drawing/2014/main" val="10003"/>
+                  </a:ext>
+                </a:extLst>
               </a:tr>
               <a:tr h="292608">
                 <a:tc>
@@ -8159,11 +8298,20 @@
                             </a:schemeClr>
                           </a:solidFill>
                         </a:rPr>
-                        <a:t xml:space="preserve">pct_mujeres</a:t>
+                        <a:t>pct_mujeres</a:t>
                       </a:r>
                     </a:p>
                   </a:txBody>
-                  <a:tcPr anchor="ctr" marL="64008" marR="64008" marT="18288" marB="18288">
+                  <a:tcPr marL="64008" marR="64008" marT="18288" marB="18288" anchor="ctr">
+                    <a:lnT w="9525" cap="flat" cmpd="sng" algn="ctr">
+                      <a:solidFill>
+                        <a:srgbClr val="C9CCDB"/>
+                      </a:solidFill>
+                      <a:prstDash val="solid"/>
+                      <a:round/>
+                      <a:headEnd type="none" w="med" len="med"/>
+                      <a:tailEnd type="none" w="med" len="med"/>
+                    </a:lnT>
                     <a:lnB w="9525" cap="flat">
                       <a:solidFill>
                         <a:srgbClr val="C9CCDB"/>
@@ -8193,11 +8341,20 @@
                             </a:schemeClr>
                           </a:solidFill>
                         </a:rPr>
-                        <a:t xml:space="preserve">1,03</a:t>
+                        <a:t>1,03</a:t>
                       </a:r>
                     </a:p>
                   </a:txBody>
-                  <a:tcPr anchor="ctr" marL="64008" marR="64008" marT="18288" marB="18288">
+                  <a:tcPr marL="64008" marR="64008" marT="18288" marB="18288" anchor="ctr">
+                    <a:lnT w="9525" cap="flat" cmpd="sng" algn="ctr">
+                      <a:solidFill>
+                        <a:srgbClr val="C9CCDB"/>
+                      </a:solidFill>
+                      <a:prstDash val="solid"/>
+                      <a:round/>
+                      <a:headEnd type="none" w="med" len="med"/>
+                      <a:tailEnd type="none" w="med" len="med"/>
+                    </a:lnT>
                     <a:lnB w="9525" cap="flat">
                       <a:solidFill>
                         <a:srgbClr val="C9CCDB"/>
@@ -8227,11 +8384,20 @@
                             </a:schemeClr>
                           </a:solidFill>
                         </a:rPr>
-                        <a:t xml:space="preserve">&lt; 0,001</a:t>
+                        <a:t>&lt; 0,001</a:t>
                       </a:r>
                     </a:p>
                   </a:txBody>
-                  <a:tcPr anchor="ctr" marL="64008" marR="64008" marT="18288" marB="18288">
+                  <a:tcPr marL="64008" marR="64008" marT="18288" marB="18288" anchor="ctr">
+                    <a:lnT w="9525" cap="flat" cmpd="sng" algn="ctr">
+                      <a:solidFill>
+                        <a:srgbClr val="C9CCDB"/>
+                      </a:solidFill>
+                      <a:prstDash val="solid"/>
+                      <a:round/>
+                      <a:headEnd type="none" w="med" len="med"/>
+                      <a:tailEnd type="none" w="med" len="med"/>
+                    </a:lnT>
                     <a:lnB w="9525" cap="flat">
                       <a:solidFill>
                         <a:srgbClr val="C9CCDB"/>
@@ -8261,11 +8427,20 @@
                             </a:schemeClr>
                           </a:solidFill>
                         </a:rPr>
-                        <a:t xml:space="preserve">No lineal</a:t>
+                        <a:t>No lineal</a:t>
                       </a:r>
                     </a:p>
                   </a:txBody>
-                  <a:tcPr anchor="ctr" marL="64008" marR="64008" marT="18288" marB="18288">
+                  <a:tcPr marL="64008" marR="64008" marT="18288" marB="18288" anchor="ctr">
+                    <a:lnT w="9525" cap="flat" cmpd="sng" algn="ctr">
+                      <a:solidFill>
+                        <a:srgbClr val="C9CCDB"/>
+                      </a:solidFill>
+                      <a:prstDash val="solid"/>
+                      <a:round/>
+                      <a:headEnd type="none" w="med" len="med"/>
+                      <a:tailEnd type="none" w="med" len="med"/>
+                    </a:lnT>
                     <a:lnB w="9525" cap="flat">
                       <a:solidFill>
                         <a:srgbClr val="C9CCDB"/>
@@ -8276,6 +8451,11 @@
                     </a:solidFill>
                   </a:tcPr>
                 </a:tc>
+                <a:extLst>
+                  <a:ext uri="{0D108BD9-81ED-4DB2-BD59-A6C34878D82A}">
+                    <a16:rowId xmlns:a16="http://schemas.microsoft.com/office/drawing/2014/main" val="10004"/>
+                  </a:ext>
+                </a:extLst>
               </a:tr>
             </a:tbl>
           </a:graphicData>
@@ -8314,7 +8494,7 @@
                   <a:srgbClr val="20236D"/>
                 </a:solidFill>
               </a:rPr>
-              <a:t xml:space="preserve">Dos límites reales</a:t>
+              <a:t>Dos límites reales</a:t>
             </a:r>
           </a:p>
           <a:p>
@@ -8332,7 +8512,7 @@
                   </a:schemeClr>
                 </a:solidFill>
               </a:rPr>
-              <a:t xml:space="preserve">Linealidad en el logit.</a:t>
+              <a:t>Linealidad en el logit.</a:t>
             </a:r>
             <a:r>
               <a:rPr lang="es-CL" sz="1250" b="0" i="0" dirty="0">
@@ -8343,7 +8523,7 @@
                   </a:schemeClr>
                 </a:solidFill>
               </a:rPr>
-              <a:t xml:space="preserve"> Box-Tidwell la rechaza en tres de las cuatro variables continuas. El modelo lineal es una aproximación y los efectos son promedios, no uniformes.</a:t>
+              <a:t> Box-Tidwell la rechaza en tres de las cuatro variables continuas. El modelo lineal es una aproximación y los efectos son promedios, no uniformes.</a:t>
             </a:r>
           </a:p>
           <a:p>
@@ -8361,7 +8541,7 @@
                   </a:schemeClr>
                 </a:solidFill>
               </a:rPr>
-              <a:t xml:space="preserve">Observaciones influyentes.</a:t>
+              <a:t>Observaciones influyentes.</a:t>
             </a:r>
             <a:r>
               <a:rPr lang="es-CL" sz="1250" b="0" i="0" dirty="0">
@@ -8372,7 +8552,7 @@
                   </a:schemeClr>
                 </a:solidFill>
               </a:rPr>
-              <a:t xml:space="preserve"> Ninguna domina: la distancia de Cook máxima es 0,0095. Pero retirar en bloque las 237 que superan 4/n mueve el coeficiente de la acreditación institucional un 87,7 %.</a:t>
+              <a:t> Ninguna domina: la distancia de Cook máxima es 0,0095. Pero retirar en bloque las 237 que superan 4/n mueve el coeficiente de la acreditación institucional un 87,7 %.</a:t>
             </a:r>
           </a:p>
         </p:txBody>
@@ -8410,7 +8590,7 @@
                   <a:srgbClr val="20236D"/>
                 </a:solidFill>
               </a:rPr>
-              <a:t xml:space="preserve">Lo que queda tranquilo</a:t>
+              <a:t>Lo que queda tranquilo</a:t>
             </a:r>
           </a:p>
           <a:p>
@@ -8430,7 +8610,7 @@
                   </a:schemeClr>
                 </a:solidFill>
               </a:rPr>
-              <a:t xml:space="preserve">Colinealidad:</a:t>
+              <a:t>Colinealidad:</a:t>
             </a:r>
             <a:r>
               <a:rPr lang="es-CL" sz="1250" b="0" i="0" dirty="0">
@@ -8441,7 +8621,7 @@
                   </a:schemeClr>
                 </a:solidFill>
               </a:rPr>
-              <a:t xml:space="preserve"> los cuatro VIF por debajo de 1,21, lejos del umbral de 5.</a:t>
+              <a:t> los cuatro VIF por debajo de 1,21, lejos del umbral de 5.</a:t>
             </a:r>
           </a:p>
           <a:p>
@@ -8461,7 +8641,7 @@
                   </a:schemeClr>
                 </a:solidFill>
               </a:rPr>
-              <a:t xml:space="preserve">Calibración:</a:t>
+              <a:t>Calibración:</a:t>
             </a:r>
             <a:r>
               <a:rPr lang="es-CL" sz="1250" b="0" i="0" dirty="0">
@@ -8472,7 +8652,7 @@
                   </a:schemeClr>
                 </a:solidFill>
               </a:rPr>
-              <a:t xml:space="preserve"> la probabilidad predicha sigue la frecuencia observada por deciles.</a:t>
+              <a:t> la probabilidad predicha sigue la frecuencia observada por deciles.</a:t>
             </a:r>
           </a:p>
           <a:p>
@@ -8492,7 +8672,7 @@
                   </a:schemeClr>
                 </a:solidFill>
               </a:rPr>
-              <a:t xml:space="preserve">Residuos:</a:t>
+              <a:t>Residuos:</a:t>
             </a:r>
             <a:r>
               <a:rPr lang="es-CL" sz="1250" b="0" i="0" dirty="0">
@@ -8503,7 +8683,7 @@
                   </a:schemeClr>
                 </a:solidFill>
               </a:rPr>
-              <a:t xml:space="preserve"> solo 28 de 6.774 con |r| &gt; 3, el 0,41 %.</a:t>
+              <a:t> solo 28 de 6.774 con |r| &gt; 3, el 0,41 %.</a:t>
             </a:r>
           </a:p>
           <a:p>
@@ -8521,7 +8701,7 @@
                   </a:schemeClr>
                 </a:solidFill>
               </a:rPr>
-              <a:t xml:space="preserve">La acreditación institucional es la variable de mayor efecto y la de menor solidez: es también la que más se ensancha al remuestrear por institución.</a:t>
+              <a:t>La acreditación institucional es la variable de mayor efecto y la de menor solidez: es también la que más se ensancha al remuestrear por institución.</a:t>
             </a:r>
           </a:p>
         </p:txBody>
@@ -8795,7 +8975,7 @@
                   <a:srgbClr val="20236D"/>
                 </a:solidFill>
               </a:rPr>
-              <a:t xml:space="preserve">SÍ PERMITE AFIRMAR</a:t>
+              <a:t>SÍ PERMITE AFIRMAR</a:t>
             </a:r>
           </a:p>
           <a:p>
@@ -8815,7 +8995,7 @@
                   </a:schemeClr>
                 </a:solidFill>
               </a:rPr>
-              <a:t xml:space="preserve">El abandono aparente se asocia de forma robusta con la acreditación, el tamaño y la composición de género del programa.</a:t>
+              <a:t>El abandono aparente se asocia de forma robusta con la acreditación, el tamaño y la composición de género del programa.</a:t>
             </a:r>
           </a:p>
           <a:p>
@@ -8835,7 +9015,7 @@
                   </a:schemeClr>
                 </a:solidFill>
               </a:rPr>
-              <a:t xml:space="preserve">El modelo discrimina claramente mejor que el azar y suma casi trece puntos de exactitud sobre la línea base.</a:t>
+              <a:t>El modelo discrimina claramente mejor que el azar y suma casi trece puntos de exactitud sobre la línea base.</a:t>
             </a:r>
           </a:p>
           <a:p>
@@ -8855,7 +9035,7 @@
                   </a:schemeClr>
                 </a:solidFill>
               </a:rPr>
-              <a:t xml:space="preserve">Las cuatro variables que lo sostienen son las mismas que resistieron el remuestreo en S2.</a:t>
+              <a:t>Las cuatro variables que lo sostienen son las mismas que resistieron el remuestreo en S2.</a:t>
             </a:r>
           </a:p>
         </p:txBody>
@@ -9039,7 +9219,7 @@
                   <a:srgbClr val="20236D"/>
                 </a:solidFill>
               </a:rPr>
-              <a:t xml:space="preserve">NO PERMITE AFIRMAR</a:t>
+              <a:t>NO PERMITE AFIRMAR</a:t>
             </a:r>
           </a:p>
           <a:p>
@@ -9059,7 +9239,7 @@
                   </a:schemeClr>
                 </a:solidFill>
               </a:rPr>
-              <a:t xml:space="preserve">Nada sobre estudiantes individuales: la unidad de análisis es el programa.</a:t>
+              <a:t>Nada sobre estudiantes individuales: la unidad de análisis es el programa.</a:t>
             </a:r>
           </a:p>
           <a:p>
@@ -9079,7 +9259,7 @@
                   </a:schemeClr>
                 </a:solidFill>
               </a:rPr>
-              <a:t xml:space="preserve">Nada sobre causas: no hay grupo de control ni variación exógena.</a:t>
+              <a:t>Nada sobre causas: no hay grupo de control ni variación exógena.</a:t>
             </a:r>
           </a:p>
           <a:p>
@@ -9099,7 +9279,7 @@
                   </a:schemeClr>
                 </a:solidFill>
               </a:rPr>
-              <a:t xml:space="preserve">Nada sobre el abandono real: lo medido es aparente.</a:t>
+              <a:t>Nada sobre el abandono real: lo medido es aparente.</a:t>
             </a:r>
           </a:p>
           <a:p>
@@ -9119,7 +9299,7 @@
                   </a:schemeClr>
                 </a:solidFill>
               </a:rPr>
-              <a:t xml:space="preserve">Nada firme sobre los efectos categóricos: al remuestrear por institución, siete de veinte pierden el signo.</a:t>
+              <a:t>Nada firme sobre los efectos categóricos: al remuestrear por institución, siete de veinte pierden el signo.</a:t>
             </a:r>
           </a:p>
         </p:txBody>
@@ -9393,7 +9573,7 @@
                   <a:srgbClr val="20236D"/>
                 </a:solidFill>
               </a:rPr>
-              <a:t xml:space="preserve">1 · IMPUTACIÓN MÚLTIPLE</a:t>
+              <a:t>1 · IMPUTACIÓN MÚLTIPLE</a:t>
             </a:r>
           </a:p>
           <a:p>
@@ -9411,7 +9591,7 @@
                   </a:schemeClr>
                 </a:solidFill>
               </a:rPr>
-              <a:t xml:space="preserve">Ninguna de las dos imputaciones propaga la incertidumbre de haber imputado: ambas tratan un valor predicho como observado.</a:t>
+              <a:t>Ninguna de las dos imputaciones propaga la incertidumbre de haber imputado: ambas tratan un valor predicho como observado.</a:t>
             </a:r>
           </a:p>
         </p:txBody>
@@ -9649,7 +9829,7 @@
                   <a:srgbClr val="20236D"/>
                 </a:solidFill>
               </a:rPr>
-              <a:t xml:space="preserve">2 · TÉRMINOS NO LINEALES</a:t>
+              <a:t>2 · TÉRMINOS NO LINEALES</a:t>
             </a:r>
           </a:p>
           <a:p>
@@ -9667,7 +9847,7 @@
                   </a:schemeClr>
                 </a:solidFill>
               </a:rPr>
-              <a:t xml:space="preserve">Para las tres variables donde Box-Tidwell rechaza la linealidad en el logit.</a:t>
+              <a:t>Para las tres variables donde Box-Tidwell rechaza la linealidad en el logit.</a:t>
             </a:r>
           </a:p>
         </p:txBody>
@@ -9711,7 +9891,7 @@
                   <a:srgbClr val="20236D"/>
                 </a:solidFill>
               </a:rPr>
-              <a:t xml:space="preserve">3 · MODELO MULTINIVEL</a:t>
+              <a:t>3 · MODELO MULTINIVEL</a:t>
             </a:r>
           </a:p>
           <a:p>
@@ -9729,7 +9909,7 @@
                   </a:schemeClr>
                 </a:solidFill>
               </a:rPr>
-              <a:t xml:space="preserve">Tratar la institución como efecto aleatorio, en lugar de limitarse a cuantificar su efecto por remuestreo.</a:t>
+              <a:t>Tratar la institución como efecto aleatorio, en lugar de limitarse a cuantificar su efecto por remuestreo.</a:t>
             </a:r>
           </a:p>
         </p:txBody>
@@ -9767,7 +9947,7 @@
                   <a:srgbClr val="20236D"/>
                 </a:solidFill>
               </a:rPr>
-              <a:t xml:space="preserve">Sobre el tratamiento de datos faltantes</a:t>
+              <a:t>Sobre el tratamiento de datos faltantes</a:t>
             </a:r>
           </a:p>
           <a:p>
@@ -9787,7 +9967,7 @@
                   </a:schemeClr>
                 </a:solidFill>
               </a:rPr>
-              <a:t xml:space="preserve">Preferir la </a:t>
+              <a:t>Preferir la </a:t>
             </a:r>
             <a:r>
               <a:rPr lang="es-CL" sz="1250" b="1" i="0" dirty="0">
@@ -9798,7 +9978,7 @@
                   </a:schemeClr>
                 </a:solidFill>
               </a:rPr>
-              <a:t xml:space="preserve">imputación por regresión</a:t>
+              <a:t>imputación por regresión</a:t>
             </a:r>
             <a:r>
               <a:rPr lang="es-CL" sz="1250" b="0" i="0" dirty="0">
@@ -9809,7 +9989,7 @@
                   </a:schemeClr>
                 </a:solidFill>
               </a:rPr>
-              <a:t xml:space="preserve">: conserva la muestra, preserva mejor las correlaciones y rinde algo más que la mediana.</a:t>
+              <a:t>: conserva la muestra, preserva mejor las correlaciones y rinde algo más que la mediana.</a:t>
             </a:r>
           </a:p>
           <a:p>
@@ -9829,7 +10009,7 @@
                   </a:schemeClr>
                 </a:solidFill>
               </a:rPr>
-              <a:t xml:space="preserve">No eliminar casos</a:t>
+              <a:t>No eliminar casos</a:t>
             </a:r>
             <a:r>
               <a:rPr lang="es-CL" sz="1250" b="0" i="0" dirty="0">
@@ -9840,7 +10020,7 @@
                   </a:schemeClr>
                 </a:solidFill>
               </a:rPr>
-              <a:t xml:space="preserve"> cuando la ausencia no es MCAR: el conjunto superviviente deja de representar al sistema.</a:t>
+              <a:t> cuando la ausencia no es MCAR: el conjunto superviviente deja de representar al sistema.</a:t>
             </a:r>
           </a:p>
           <a:p>
@@ -9860,7 +10040,7 @@
                   </a:schemeClr>
                 </a:solidFill>
               </a:rPr>
-              <a:t xml:space="preserve">Declarar siempre el mecanismo supuesto</a:t>
+              <a:t>Declarar siempre el mecanismo supuesto</a:t>
             </a:r>
             <a:r>
               <a:rPr lang="es-CL" sz="1250" b="0" i="0" dirty="0">
@@ -9871,7 +10051,7 @@
                   </a:schemeClr>
                 </a:solidFill>
               </a:rPr>
-              <a:t xml:space="preserve">: bajo MNAR ninguna estrategia es insesgada.</a:t>
+              <a:t>: bajo MNAR ninguna estrategia es insesgada.</a:t>
             </a:r>
           </a:p>
           <a:p>
@@ -9891,7 +10071,7 @@
                   </a:schemeClr>
                 </a:solidFill>
               </a:rPr>
-              <a:t xml:space="preserve">Tratar como </a:t>
+              <a:t>Tratar como </a:t>
             </a:r>
             <a:r>
               <a:rPr lang="es-CL" sz="1250" b="1" i="0" dirty="0">
@@ -9902,7 +10082,7 @@
                   </a:schemeClr>
                 </a:solidFill>
               </a:rPr>
-              <a:t xml:space="preserve">optimista</a:t>
+              <a:t>optimista</a:t>
             </a:r>
             <a:r>
               <a:rPr lang="es-CL" sz="1250" b="0" i="0" dirty="0">
@@ -9913,7 +10093,7 @@
                   </a:schemeClr>
                 </a:solidFill>
               </a:rPr>
-              <a:t xml:space="preserve"> todo intervalo posterior a una imputación simple.</a:t>
+              <a:t> todo intervalo posterior a una imputación simple.</a:t>
             </a:r>
           </a:p>
         </p:txBody>
@@ -9954,7 +10134,7 @@
                   </a:schemeClr>
                 </a:solidFill>
               </a:rPr>
-              <a:t xml:space="preserve">La progresión completa: S1 describió y midió · S2 puso a prueba y validó · S3 modela y predice sobre lo que quedó en pie.</a:t>
+              <a:t>La progresión completa: S1 describió y midió · S2 puso a prueba y validó · S3 modela y predice sobre lo que quedó en pie.</a:t>
             </a:r>
           </a:p>
         </p:txBody>
@@ -9978,7 +10158,7 @@
     <p:bg>
       <p:bgPr>
         <a:blipFill dpi="0" rotWithShape="1">
-          <a:blip r:embed="rId2">
+          <a:blip r:embed="rId3">
             <a:lum/>
           </a:blip>
           <a:srcRect/>
@@ -10018,7 +10198,7 @@
           <p:nvPr/>
         </p:nvPicPr>
         <p:blipFill>
-          <a:blip r:embed="rId3"/>
+          <a:blip r:embed="rId4"/>
           <a:stretch>
             <a:fillRect/>
           </a:stretch>
@@ -10302,7 +10482,7 @@
                   <a:srgbClr val="20236D"/>
                 </a:solidFill>
               </a:rPr>
-              <a:t xml:space="preserve">9.678</a:t>
+              <a:t>9.678</a:t>
             </a:r>
           </a:p>
           <a:p>
@@ -10320,7 +10500,7 @@
                   </a:schemeClr>
                 </a:solidFill>
               </a:rPr>
-              <a:t xml:space="preserve">programas de pregrado, construidos desde las bases SIES de matrícula 2007–2026 y titulados 2007–2025</a:t>
+              <a:t>programas de pregrado, construidos desde las bases SIES de matrícula 2007–2026 y titulados 2007–2025</a:t>
             </a:r>
           </a:p>
         </p:txBody>
@@ -10558,7 +10738,7 @@
                   <a:srgbClr val="20236D"/>
                 </a:solidFill>
               </a:rPr>
-              <a:t xml:space="preserve">0,518</a:t>
+              <a:t>0,518</a:t>
             </a:r>
           </a:p>
           <a:p>
@@ -10576,7 +10756,7 @@
                   </a:schemeClr>
                 </a:solidFill>
               </a:rPr>
-              <a:t xml:space="preserve">abandono aparente medio del sistema, con una dispersión enorme entre programas</a:t>
+              <a:t>abandono aparente medio del sistema, con una dispersión enorme entre programas</a:t>
             </a:r>
           </a:p>
         </p:txBody>
@@ -10620,7 +10800,7 @@
                   <a:srgbClr val="20236D"/>
                 </a:solidFill>
               </a:rPr>
-              <a:t xml:space="preserve">168</a:t>
+              <a:t>168</a:t>
             </a:r>
           </a:p>
           <a:p>
@@ -10638,7 +10818,7 @@
                   </a:schemeClr>
                 </a:solidFill>
               </a:rPr>
-              <a:t xml:space="preserve">instituciones: los programas de una misma institución no son independientes</a:t>
+              <a:t>instituciones: los programas de una misma institución no son independientes</a:t>
             </a:r>
           </a:p>
         </p:txBody>
@@ -10676,7 +10856,7 @@
                   <a:srgbClr val="20236D"/>
                 </a:solidFill>
               </a:rPr>
-              <a:t xml:space="preserve">La pregunta que organiza el proyecto</a:t>
+              <a:t>La pregunta que organiza el proyecto</a:t>
             </a:r>
           </a:p>
           <a:p>
@@ -10694,7 +10874,7 @@
                   </a:schemeClr>
                 </a:solidFill>
               </a:rPr>
-              <a:t xml:space="preserve">¿Puede anticiparse el abandono de un programa a partir de atributos observables, para focalizar recursos de retención antes de que el problema se consolide?</a:t>
+              <a:t>¿Puede anticiparse el abandono de un programa a partir de atributos observables, para focalizar recursos de retención antes de que el problema se consolide?</a:t>
             </a:r>
           </a:p>
           <a:p>
@@ -10712,7 +10892,7 @@
                   </a:schemeClr>
                 </a:solidFill>
               </a:rPr>
-              <a:t xml:space="preserve">Dos precisiones que condicionan todo lo que sigue: la unidad de análisis es el </a:t>
+              <a:t>Dos precisiones que condicionan todo lo que sigue: la unidad de análisis es el </a:t>
             </a:r>
             <a:r>
               <a:rPr lang="es-CL" sz="1300" b="1" i="0" dirty="0">
@@ -10723,7 +10903,7 @@
                   </a:schemeClr>
                 </a:solidFill>
               </a:rPr>
-              <a:t xml:space="preserve">programa, no el estudiante</a:t>
+              <a:t>programa, no el estudiante</a:t>
             </a:r>
             <a:r>
               <a:rPr lang="es-CL" sz="1300" b="0" i="0" dirty="0">
@@ -10734,7 +10914,7 @@
                   </a:schemeClr>
                 </a:solidFill>
               </a:rPr>
-              <a:t xml:space="preserve">, y lo que se mide es </a:t>
+              <a:t>, y lo que se mide es </a:t>
             </a:r>
             <a:r>
               <a:rPr lang="es-CL" sz="1300" b="1" i="0" dirty="0">
@@ -10745,7 +10925,7 @@
                   </a:schemeClr>
                 </a:solidFill>
               </a:rPr>
-              <a:t xml:space="preserve">abandono aparente</a:t>
+              <a:t>abandono aparente</a:t>
             </a:r>
             <a:r>
               <a:rPr lang="es-CL" sz="1300" b="0" i="0" dirty="0">
@@ -10756,7 +10936,7 @@
                   </a:schemeClr>
                 </a:solidFill>
               </a:rPr>
-              <a:t xml:space="preserve">, de modo que quien se cambia de carrera y se titula en otra parte cuenta aquí como abandono.</a:t>
+              <a:t>, de modo que quien se cambia de carrera y se titula en otra parte cuenta aquí como abandono.</a:t>
             </a:r>
           </a:p>
         </p:txBody>
@@ -10865,7 +11045,7 @@
                   <a:srgbClr val="20236D"/>
                 </a:solidFill>
               </a:rPr>
-              <a:t xml:space="preserve">Metodología</a:t>
+              <a:t>Metodología</a:t>
             </a:r>
           </a:p>
           <a:p>
@@ -10880,7 +11060,7 @@
                   <a:srgbClr val="20236D"/>
                 </a:solidFill>
               </a:rPr>
-              <a:t xml:space="preserve">La cadena S1 → S2 → S3</a:t>
+              <a:t>La cadena S1 → S2 → S3</a:t>
             </a:r>
           </a:p>
           <a:p>
@@ -10898,7 +11078,7 @@
                   </a:schemeClr>
                 </a:solidFill>
               </a:rPr>
-              <a:t xml:space="preserve">Ninguna decisión metodológica de esta fase es nueva: todas provienen de un resultado de las fases anteriores.</a:t>
+              <a:t>Ninguna decisión metodológica de esta fase es nueva: todas provienen de un resultado de las fases anteriores.</a:t>
             </a:r>
           </a:p>
         </p:txBody>
@@ -11372,7 +11552,7 @@
                   <a:srgbClr val="20236D"/>
                 </a:solidFill>
               </a:rPr>
-              <a:t xml:space="preserve">S1 · DESCRIBIÓ Y MIDIÓ</a:t>
+              <a:t>S1 · DESCRIBIÓ Y MIDIÓ</a:t>
             </a:r>
           </a:p>
           <a:p>
@@ -11392,7 +11572,7 @@
                   </a:schemeClr>
                 </a:solidFill>
               </a:rPr>
-              <a:t xml:space="preserve">Abandono medio 0,518 y su dispersión</a:t>
+              <a:t>Abandono medio 0,518 y su dispersión</a:t>
             </a:r>
           </a:p>
           <a:p>
@@ -11412,7 +11592,7 @@
                   </a:schemeClr>
                 </a:solidFill>
               </a:rPr>
-              <a:t xml:space="preserve">Nueve variables asociadas al abandono</a:t>
+              <a:t>Nueve variables asociadas al abandono</a:t>
             </a:r>
           </a:p>
           <a:p>
@@ -11432,7 +11612,7 @@
                   </a:schemeClr>
                 </a:solidFill>
               </a:rPr>
-              <a:t xml:space="preserve">465 programas censurados en 0 y en 1</a:t>
+              <a:t>465 programas censurados en 0 y en 1</a:t>
             </a:r>
           </a:p>
           <a:p>
@@ -11452,7 +11632,7 @@
                   </a:schemeClr>
                 </a:solidFill>
               </a:rPr>
-              <a:t xml:space="preserve">Cero datos faltantes en 25 variables</a:t>
+              <a:t>Cero datos faltantes en 25 variables</a:t>
             </a:r>
           </a:p>
         </p:txBody>
@@ -11690,7 +11870,7 @@
                   <a:srgbClr val="20236D"/>
                 </a:solidFill>
               </a:rPr>
-              <a:t xml:space="preserve">S2 · PUSO A PRUEBA</a:t>
+              <a:t>S2 · PUSO A PRUEBA</a:t>
             </a:r>
           </a:p>
           <a:p>
@@ -11710,7 +11890,7 @@
                   </a:schemeClr>
                 </a:solidFill>
               </a:rPr>
-              <a:t xml:space="preserve">Bootstrap: los IC clásicos eran fiables</a:t>
+              <a:t>Bootstrap: los IC clásicos eran fiables</a:t>
             </a:r>
           </a:p>
           <a:p>
@@ -11730,7 +11910,7 @@
                   </a:schemeClr>
                 </a:solidFill>
               </a:rPr>
-              <a:t xml:space="preserve">Permutación sin suponer normalidad</a:t>
+              <a:t>Permutación sin suponer normalidad</a:t>
             </a:r>
           </a:p>
           <a:p>
@@ -11750,7 +11930,7 @@
                   </a:schemeClr>
                 </a:solidFill>
               </a:rPr>
-              <a:t xml:space="preserve">Separó correlaciones sólidas de débiles</a:t>
+              <a:t>Separó correlaciones sólidas de débiles</a:t>
             </a:r>
           </a:p>
           <a:p>
@@ -11770,7 +11950,7 @@
                   </a:schemeClr>
                 </a:solidFill>
               </a:rPr>
-              <a:t xml:space="preserve">Advirtió: los programas no son independientes</a:t>
+              <a:t>Advirtió: los programas no son independientes</a:t>
             </a:r>
           </a:p>
         </p:txBody>
@@ -11814,7 +11994,7 @@
                   <a:srgbClr val="20236D"/>
                 </a:solidFill>
               </a:rPr>
-              <a:t xml:space="preserve">S3 · MODELA Y PREDICE</a:t>
+              <a:t>S3 · MODELA Y PREDICE</a:t>
             </a:r>
           </a:p>
           <a:p>
@@ -11834,7 +12014,7 @@
                   </a:schemeClr>
                 </a:solidFill>
               </a:rPr>
-              <a:t xml:space="preserve">Imputación informada por la matriz de S1</a:t>
+              <a:t>Imputación informada por la matriz de S1</a:t>
             </a:r>
           </a:p>
           <a:p>
@@ -11854,7 +12034,7 @@
                   </a:schemeClr>
                 </a:solidFill>
               </a:rPr>
-              <a:t xml:space="preserve">Modelo con las variables estables de S2</a:t>
+              <a:t>Modelo con las variables estables de S2</a:t>
             </a:r>
           </a:p>
           <a:p>
@@ -11874,7 +12054,7 @@
                   </a:schemeClr>
                 </a:solidFill>
               </a:rPr>
-              <a:t xml:space="preserve">Partición 70/30 estratificada, semilla 42</a:t>
+              <a:t>Partición 70/30 estratificada, semilla 42</a:t>
             </a:r>
           </a:p>
           <a:p>
@@ -11894,7 +12074,7 @@
                   </a:schemeClr>
                 </a:solidFill>
               </a:rPr>
-              <a:t xml:space="preserve">Bootstrap aplicado a los coeficientes</a:t>
+              <a:t>Bootstrap aplicado a los coeficientes</a:t>
             </a:r>
           </a:p>
         </p:txBody>
@@ -11935,7 +12115,7 @@
                   </a:schemeClr>
                 </a:solidFill>
               </a:rPr>
-              <a:t xml:space="preserve">Cada columna es consecuencia directa de la anterior: esta fase no abre líneas nuevas, cierra las que S1 y S2 dejaron abiertas.</a:t>
+              <a:t>Cada columna es consecuencia directa de la anterior: esta fase no abre líneas nuevas, cierra las que S1 y S2 dejaron abiertas.</a:t>
             </a:r>
           </a:p>
         </p:txBody>
@@ -12271,12 +12451,24 @@
         <a:graphic>
           <a:graphicData uri="http://schemas.openxmlformats.org/drawingml/2006/table">
             <a:tbl>
-              <a:tblPr firstRow="0" bandRow="0">
+              <a:tblPr>
                 <a:tableStyleId>{2D5ABB26-0587-4C30-8999-92F81FD0307C}</a:tableStyleId>
               </a:tblPr>
               <a:tblGrid>
-                <a:gridCol w="3704383"/>
-                <a:gridCol w="4260040"/>
+                <a:gridCol w="3704383">
+                  <a:extLst>
+                    <a:ext uri="{9D8B030D-6E8A-4147-A177-3AD203B41FA5}">
+                      <a16:colId xmlns:a16="http://schemas.microsoft.com/office/drawing/2014/main" val="20000"/>
+                    </a:ext>
+                  </a:extLst>
+                </a:gridCol>
+                <a:gridCol w="4260040">
+                  <a:extLst>
+                    <a:ext uri="{9D8B030D-6E8A-4147-A177-3AD203B41FA5}">
+                      <a16:colId xmlns:a16="http://schemas.microsoft.com/office/drawing/2014/main" val="20001"/>
+                    </a:ext>
+                  </a:extLst>
+                </a:gridCol>
               </a:tblGrid>
               <a:tr h="402336">
                 <a:tc>
@@ -12295,11 +12487,11 @@
                             <a:srgbClr val="FFFFFF"/>
                           </a:solidFill>
                         </a:rPr>
-                        <a:t xml:space="preserve">Decisión tomada en la Sumativa 3</a:t>
+                        <a:t>Decisión tomada en la Sumativa 3</a:t>
                       </a:r>
                     </a:p>
                   </a:txBody>
-                  <a:tcPr anchor="ctr" marL="64008" marR="64008" marT="18288" marB="18288">
+                  <a:tcPr marL="64008" marR="64008" marT="18288" marB="18288" anchor="ctr">
                     <a:solidFill>
                       <a:srgbClr val="20236D"/>
                     </a:solidFill>
@@ -12321,16 +12513,21 @@
                             <a:srgbClr val="FFFFFF"/>
                           </a:solidFill>
                         </a:rPr>
-                        <a:t xml:space="preserve">Resultado anterior que la justifica</a:t>
+                        <a:t>Resultado anterior que la justifica</a:t>
                       </a:r>
                     </a:p>
                   </a:txBody>
-                  <a:tcPr anchor="ctr" marL="64008" marR="64008" marT="18288" marB="18288">
+                  <a:tcPr marL="64008" marR="64008" marT="18288" marB="18288" anchor="ctr">
                     <a:solidFill>
                       <a:srgbClr val="20236D"/>
                     </a:solidFill>
                   </a:tcPr>
                 </a:tc>
+                <a:extLst>
+                  <a:ext uri="{0D108BD9-81ED-4DB2-BD59-A6C34878D82A}">
+                    <a16:rowId xmlns:a16="http://schemas.microsoft.com/office/drawing/2014/main" val="10000"/>
+                  </a:ext>
+                </a:extLst>
               </a:tr>
               <a:tr h="420624">
                 <a:tc>
@@ -12352,11 +12549,11 @@
                             </a:schemeClr>
                           </a:solidFill>
                         </a:rPr>
-                        <a:t xml:space="preserve">Predictoras de los modelos de imputación</a:t>
+                        <a:t>Predictoras de los modelos de imputación</a:t>
                       </a:r>
                     </a:p>
                   </a:txBody>
-                  <a:tcPr anchor="ctr" marL="64008" marR="64008" marT="18288" marB="18288">
+                  <a:tcPr marL="64008" marR="64008" marT="18288" marB="18288" anchor="ctr">
                     <a:lnB w="9525" cap="flat">
                       <a:solidFill>
                         <a:srgbClr val="C9CCDB"/>
@@ -12386,11 +12583,11 @@
                             </a:schemeClr>
                           </a:solidFill>
                         </a:rPr>
-                        <a:t xml:space="preserve">La matriz de correlaciones de S1</a:t>
+                        <a:t>La matriz de correlaciones de S1</a:t>
                       </a:r>
                     </a:p>
                   </a:txBody>
-                  <a:tcPr anchor="ctr" marL="64008" marR="64008" marT="18288" marB="18288">
+                  <a:tcPr marL="64008" marR="64008" marT="18288" marB="18288" anchor="ctr">
                     <a:lnB w="9525" cap="flat">
                       <a:solidFill>
                         <a:srgbClr val="C9CCDB"/>
@@ -12401,6 +12598,11 @@
                     </a:solidFill>
                   </a:tcPr>
                 </a:tc>
+                <a:extLst>
+                  <a:ext uri="{0D108BD9-81ED-4DB2-BD59-A6C34878D82A}">
+                    <a16:rowId xmlns:a16="http://schemas.microsoft.com/office/drawing/2014/main" val="10001"/>
+                  </a:ext>
+                </a:extLst>
               </a:tr>
               <a:tr h="420624">
                 <a:tc>
@@ -12422,11 +12624,20 @@
                             </a:schemeClr>
                           </a:solidFill>
                         </a:rPr>
-                        <a:t xml:space="preserve">Variables del modelo logístico</a:t>
+                        <a:t>Variables del modelo logístico</a:t>
                       </a:r>
                     </a:p>
                   </a:txBody>
-                  <a:tcPr anchor="ctr" marL="64008" marR="64008" marT="18288" marB="18288">
+                  <a:tcPr marL="64008" marR="64008" marT="18288" marB="18288" anchor="ctr">
+                    <a:lnT w="9525" cap="flat" cmpd="sng" algn="ctr">
+                      <a:solidFill>
+                        <a:srgbClr val="C9CCDB"/>
+                      </a:solidFill>
+                      <a:prstDash val="solid"/>
+                      <a:round/>
+                      <a:headEnd type="none" w="med" len="med"/>
+                      <a:tailEnd type="none" w="med" len="med"/>
+                    </a:lnT>
                     <a:lnB w="9525" cap="flat">
                       <a:solidFill>
                         <a:srgbClr val="C9CCDB"/>
@@ -12456,11 +12667,20 @@
                             </a:schemeClr>
                           </a:solidFill>
                         </a:rPr>
-                        <a:t xml:space="preserve">El filtro de estabilidad por bootstrap de S2</a:t>
+                        <a:t>El filtro de estabilidad por bootstrap de S2</a:t>
                       </a:r>
                     </a:p>
                   </a:txBody>
-                  <a:tcPr anchor="ctr" marL="64008" marR="64008" marT="18288" marB="18288">
+                  <a:tcPr marL="64008" marR="64008" marT="18288" marB="18288" anchor="ctr">
+                    <a:lnT w="9525" cap="flat" cmpd="sng" algn="ctr">
+                      <a:solidFill>
+                        <a:srgbClr val="C9CCDB"/>
+                      </a:solidFill>
+                      <a:prstDash val="solid"/>
+                      <a:round/>
+                      <a:headEnd type="none" w="med" len="med"/>
+                      <a:tailEnd type="none" w="med" len="med"/>
+                    </a:lnT>
                     <a:lnB w="9525" cap="flat">
                       <a:solidFill>
                         <a:srgbClr val="C9CCDB"/>
@@ -12471,6 +12691,11 @@
                     </a:solidFill>
                   </a:tcPr>
                 </a:tc>
+                <a:extLst>
+                  <a:ext uri="{0D108BD9-81ED-4DB2-BD59-A6C34878D82A}">
+                    <a16:rowId xmlns:a16="http://schemas.microsoft.com/office/drawing/2014/main" val="10002"/>
+                  </a:ext>
+                </a:extLst>
               </a:tr>
               <a:tr h="420624">
                 <a:tc>
@@ -12492,11 +12717,20 @@
                             </a:schemeClr>
                           </a:solidFill>
                         </a:rPr>
-                        <a:t xml:space="preserve">Conservar los 465 programas censurados</a:t>
+                        <a:t>Conservar los 465 programas censurados</a:t>
                       </a:r>
                     </a:p>
                   </a:txBody>
-                  <a:tcPr anchor="ctr" marL="64008" marR="64008" marT="18288" marB="18288">
+                  <a:tcPr marL="64008" marR="64008" marT="18288" marB="18288" anchor="ctr">
+                    <a:lnT w="9525" cap="flat" cmpd="sng" algn="ctr">
+                      <a:solidFill>
+                        <a:srgbClr val="C9CCDB"/>
+                      </a:solidFill>
+                      <a:prstDash val="solid"/>
+                      <a:round/>
+                      <a:headEnd type="none" w="med" len="med"/>
+                      <a:tailEnd type="none" w="med" len="med"/>
+                    </a:lnT>
                     <a:lnB w="9525" cap="flat">
                       <a:solidFill>
                         <a:srgbClr val="C9CCDB"/>
@@ -12526,11 +12760,20 @@
                             </a:schemeClr>
                           </a:solidFill>
                         </a:rPr>
-                        <a:t xml:space="preserve">La auditoría caso a caso que hizo S2</a:t>
+                        <a:t>La auditoría caso a caso que hizo S2</a:t>
                       </a:r>
                     </a:p>
                   </a:txBody>
-                  <a:tcPr anchor="ctr" marL="64008" marR="64008" marT="18288" marB="18288">
+                  <a:tcPr marL="64008" marR="64008" marT="18288" marB="18288" anchor="ctr">
+                    <a:lnT w="9525" cap="flat" cmpd="sng" algn="ctr">
+                      <a:solidFill>
+                        <a:srgbClr val="C9CCDB"/>
+                      </a:solidFill>
+                      <a:prstDash val="solid"/>
+                      <a:round/>
+                      <a:headEnd type="none" w="med" len="med"/>
+                      <a:tailEnd type="none" w="med" len="med"/>
+                    </a:lnT>
                     <a:lnB w="9525" cap="flat">
                       <a:solidFill>
                         <a:srgbClr val="C9CCDB"/>
@@ -12541,6 +12784,11 @@
                     </a:solidFill>
                   </a:tcPr>
                 </a:tc>
+                <a:extLst>
+                  <a:ext uri="{0D108BD9-81ED-4DB2-BD59-A6C34878D82A}">
+                    <a16:rowId xmlns:a16="http://schemas.microsoft.com/office/drawing/2014/main" val="10003"/>
+                  </a:ext>
+                </a:extLst>
               </a:tr>
               <a:tr h="420624">
                 <a:tc>
@@ -12562,11 +12810,20 @@
                             </a:schemeClr>
                           </a:solidFill>
                         </a:rPr>
-                        <a:t xml:space="preserve">Umbral del 50 % en la variable respuesta</a:t>
+                        <a:t>Umbral del 50 % en la variable respuesta</a:t>
                       </a:r>
                     </a:p>
                   </a:txBody>
-                  <a:tcPr anchor="ctr" marL="64008" marR="64008" marT="18288" marB="18288">
+                  <a:tcPr marL="64008" marR="64008" marT="18288" marB="18288" anchor="ctr">
+                    <a:lnT w="9525" cap="flat" cmpd="sng" algn="ctr">
+                      <a:solidFill>
+                        <a:srgbClr val="C9CCDB"/>
+                      </a:solidFill>
+                      <a:prstDash val="solid"/>
+                      <a:round/>
+                      <a:headEnd type="none" w="med" len="med"/>
+                      <a:tailEnd type="none" w="med" len="med"/>
+                    </a:lnT>
                     <a:lnB w="9525" cap="flat">
                       <a:solidFill>
                         <a:srgbClr val="C9CCDB"/>
@@ -12596,11 +12853,20 @@
                             </a:schemeClr>
                           </a:solidFill>
                         </a:rPr>
-                        <a:t xml:space="preserve">El 54,94 % de S1, validado por Wilson y Z en S2</a:t>
+                        <a:t>El 54,94 % de S1, validado por Wilson y Z en S2</a:t>
                       </a:r>
                     </a:p>
                   </a:txBody>
-                  <a:tcPr anchor="ctr" marL="64008" marR="64008" marT="18288" marB="18288">
+                  <a:tcPr marL="64008" marR="64008" marT="18288" marB="18288" anchor="ctr">
+                    <a:lnT w="9525" cap="flat" cmpd="sng" algn="ctr">
+                      <a:solidFill>
+                        <a:srgbClr val="C9CCDB"/>
+                      </a:solidFill>
+                      <a:prstDash val="solid"/>
+                      <a:round/>
+                      <a:headEnd type="none" w="med" len="med"/>
+                      <a:tailEnd type="none" w="med" len="med"/>
+                    </a:lnT>
                     <a:lnB w="9525" cap="flat">
                       <a:solidFill>
                         <a:srgbClr val="C9CCDB"/>
@@ -12611,6 +12877,11 @@
                     </a:solidFill>
                   </a:tcPr>
                 </a:tc>
+                <a:extLst>
+                  <a:ext uri="{0D108BD9-81ED-4DB2-BD59-A6C34878D82A}">
+                    <a16:rowId xmlns:a16="http://schemas.microsoft.com/office/drawing/2014/main" val="10004"/>
+                  </a:ext>
+                </a:extLst>
               </a:tr>
               <a:tr h="420624">
                 <a:tc>
@@ -12632,11 +12903,20 @@
                             </a:schemeClr>
                           </a:solidFill>
                         </a:rPr>
-                        <a:t xml:space="preserve">Bootstrap de los coeficientes del modelo</a:t>
+                        <a:t>Bootstrap de los coeficientes del modelo</a:t>
                       </a:r>
                     </a:p>
                   </a:txBody>
-                  <a:tcPr anchor="ctr" marL="64008" marR="64008" marT="18288" marB="18288">
+                  <a:tcPr marL="64008" marR="64008" marT="18288" marB="18288" anchor="ctr">
+                    <a:lnT w="9525" cap="flat" cmpd="sng" algn="ctr">
+                      <a:solidFill>
+                        <a:srgbClr val="C9CCDB"/>
+                      </a:solidFill>
+                      <a:prstDash val="solid"/>
+                      <a:round/>
+                      <a:headEnd type="none" w="med" len="med"/>
+                      <a:tailEnd type="none" w="med" len="med"/>
+                    </a:lnT>
                     <a:lnB w="9525" cap="flat">
                       <a:solidFill>
                         <a:srgbClr val="C9CCDB"/>
@@ -12666,11 +12946,20 @@
                             </a:schemeClr>
                           </a:solidFill>
                         </a:rPr>
-                        <a:t xml:space="preserve">El mismo instrumento que S2 aplicó a medias</a:t>
+                        <a:t>El mismo instrumento que S2 aplicó a medias</a:t>
                       </a:r>
                     </a:p>
                   </a:txBody>
-                  <a:tcPr anchor="ctr" marL="64008" marR="64008" marT="18288" marB="18288">
+                  <a:tcPr marL="64008" marR="64008" marT="18288" marB="18288" anchor="ctr">
+                    <a:lnT w="9525" cap="flat" cmpd="sng" algn="ctr">
+                      <a:solidFill>
+                        <a:srgbClr val="C9CCDB"/>
+                      </a:solidFill>
+                      <a:prstDash val="solid"/>
+                      <a:round/>
+                      <a:headEnd type="none" w="med" len="med"/>
+                      <a:tailEnd type="none" w="med" len="med"/>
+                    </a:lnT>
                     <a:lnB w="9525" cap="flat">
                       <a:solidFill>
                         <a:srgbClr val="C9CCDB"/>
@@ -12681,6 +12970,11 @@
                     </a:solidFill>
                   </a:tcPr>
                 </a:tc>
+                <a:extLst>
+                  <a:ext uri="{0D108BD9-81ED-4DB2-BD59-A6C34878D82A}">
+                    <a16:rowId xmlns:a16="http://schemas.microsoft.com/office/drawing/2014/main" val="10005"/>
+                  </a:ext>
+                </a:extLst>
               </a:tr>
               <a:tr h="420624">
                 <a:tc>
@@ -12702,11 +12996,20 @@
                             </a:schemeClr>
                           </a:solidFill>
                         </a:rPr>
-                        <a:t xml:space="preserve">Bootstrap por institución, como extensión</a:t>
+                        <a:t>Bootstrap por institución, como extensión</a:t>
                       </a:r>
                     </a:p>
                   </a:txBody>
-                  <a:tcPr anchor="ctr" marL="64008" marR="64008" marT="18288" marB="18288">
+                  <a:tcPr marL="64008" marR="64008" marT="18288" marB="18288" anchor="ctr">
+                    <a:lnT w="9525" cap="flat" cmpd="sng" algn="ctr">
+                      <a:solidFill>
+                        <a:srgbClr val="C9CCDB"/>
+                      </a:solidFill>
+                      <a:prstDash val="solid"/>
+                      <a:round/>
+                      <a:headEnd type="none" w="med" len="med"/>
+                      <a:tailEnd type="none" w="med" len="med"/>
+                    </a:lnT>
                     <a:lnB w="9525" cap="flat">
                       <a:solidFill>
                         <a:srgbClr val="C9CCDB"/>
@@ -12736,11 +13039,20 @@
                             </a:schemeClr>
                           </a:solidFill>
                         </a:rPr>
-                        <a:t xml:space="preserve">La advertencia de S2 sobre la no independencia</a:t>
+                        <a:t>La advertencia de S2 sobre la no independencia</a:t>
                       </a:r>
                     </a:p>
                   </a:txBody>
-                  <a:tcPr anchor="ctr" marL="64008" marR="64008" marT="18288" marB="18288">
+                  <a:tcPr marL="64008" marR="64008" marT="18288" marB="18288" anchor="ctr">
+                    <a:lnT w="9525" cap="flat" cmpd="sng" algn="ctr">
+                      <a:solidFill>
+                        <a:srgbClr val="C9CCDB"/>
+                      </a:solidFill>
+                      <a:prstDash val="solid"/>
+                      <a:round/>
+                      <a:headEnd type="none" w="med" len="med"/>
+                      <a:tailEnd type="none" w="med" len="med"/>
+                    </a:lnT>
                     <a:lnB w="9525" cap="flat">
                       <a:solidFill>
                         <a:srgbClr val="C9CCDB"/>
@@ -12751,6 +13063,11 @@
                     </a:solidFill>
                   </a:tcPr>
                 </a:tc>
+                <a:extLst>
+                  <a:ext uri="{0D108BD9-81ED-4DB2-BD59-A6C34878D82A}">
+                    <a16:rowId xmlns:a16="http://schemas.microsoft.com/office/drawing/2014/main" val="10006"/>
+                  </a:ext>
+                </a:extLst>
               </a:tr>
             </a:tbl>
           </a:graphicData>
@@ -12792,7 +13109,7 @@
                   </a:schemeClr>
                 </a:solidFill>
               </a:rPr>
-              <a:t xml:space="preserve">La columna izquierda no contiene ninguna decisión que se haya tomado en esta fase sin un antecedente documentado.</a:t>
+              <a:t>La columna izquierda no contiene ninguna decisión que se haya tomado en esta fase sin un antecedente documentado.</a:t>
             </a:r>
           </a:p>
         </p:txBody>
@@ -13128,14 +13445,38 @@
         <a:graphic>
           <a:graphicData uri="http://schemas.openxmlformats.org/drawingml/2006/table">
             <a:tbl>
-              <a:tblPr firstRow="0" bandRow="0">
+              <a:tblPr>
                 <a:tableStyleId>{2D5ABB26-0587-4C30-8999-92F81FD0307C}</a:tableStyleId>
               </a:tblPr>
               <a:tblGrid>
-                <a:gridCol w="1619655"/>
-                <a:gridCol w="1079770"/>
-                <a:gridCol w="1079770"/>
-                <a:gridCol w="1295724"/>
+                <a:gridCol w="1619655">
+                  <a:extLst>
+                    <a:ext uri="{9D8B030D-6E8A-4147-A177-3AD203B41FA5}">
+                      <a16:colId xmlns:a16="http://schemas.microsoft.com/office/drawing/2014/main" val="20000"/>
+                    </a:ext>
+                  </a:extLst>
+                </a:gridCol>
+                <a:gridCol w="1079770">
+                  <a:extLst>
+                    <a:ext uri="{9D8B030D-6E8A-4147-A177-3AD203B41FA5}">
+                      <a16:colId xmlns:a16="http://schemas.microsoft.com/office/drawing/2014/main" val="20001"/>
+                    </a:ext>
+                  </a:extLst>
+                </a:gridCol>
+                <a:gridCol w="1079770">
+                  <a:extLst>
+                    <a:ext uri="{9D8B030D-6E8A-4147-A177-3AD203B41FA5}">
+                      <a16:colId xmlns:a16="http://schemas.microsoft.com/office/drawing/2014/main" val="20002"/>
+                    </a:ext>
+                  </a:extLst>
+                </a:gridCol>
+                <a:gridCol w="1295724">
+                  <a:extLst>
+                    <a:ext uri="{9D8B030D-6E8A-4147-A177-3AD203B41FA5}">
+                      <a16:colId xmlns:a16="http://schemas.microsoft.com/office/drawing/2014/main" val="20003"/>
+                    </a:ext>
+                  </a:extLst>
+                </a:gridCol>
               </a:tblGrid>
               <a:tr h="329184">
                 <a:tc>
@@ -13154,11 +13495,11 @@
                             <a:srgbClr val="FFFFFF"/>
                           </a:solidFill>
                         </a:rPr>
-                        <a:t xml:space="preserve">Variable</a:t>
+                        <a:t>Variable</a:t>
                       </a:r>
                     </a:p>
                   </a:txBody>
-                  <a:tcPr anchor="ctr" marL="64008" marR="64008" marT="18288" marB="18288">
+                  <a:tcPr marL="64008" marR="64008" marT="18288" marB="18288" anchor="ctr">
                     <a:solidFill>
                       <a:srgbClr val="20236D"/>
                     </a:solidFill>
@@ -13180,11 +13521,11 @@
                             <a:srgbClr val="FFFFFF"/>
                           </a:solidFill>
                         </a:rPr>
-                        <a:t xml:space="preserve">Mecanismo</a:t>
+                        <a:t>Mecanismo</a:t>
                       </a:r>
                     </a:p>
                   </a:txBody>
-                  <a:tcPr anchor="ctr" marL="64008" marR="64008" marT="18288" marB="18288">
+                  <a:tcPr marL="64008" marR="64008" marT="18288" marB="18288" anchor="ctr">
                     <a:solidFill>
                       <a:srgbClr val="20236D"/>
                     </a:solidFill>
@@ -13206,11 +13547,11 @@
                             <a:srgbClr val="FFFFFF"/>
                           </a:solidFill>
                         </a:rPr>
-                        <a:t xml:space="preserve">Ausencia</a:t>
+                        <a:t>Ausencia</a:t>
                       </a:r>
                     </a:p>
                   </a:txBody>
-                  <a:tcPr anchor="ctr" marL="64008" marR="64008" marT="18288" marB="18288">
+                  <a:tcPr marL="64008" marR="64008" marT="18288" marB="18288" anchor="ctr">
                     <a:solidFill>
                       <a:srgbClr val="20236D"/>
                     </a:solidFill>
@@ -13232,16 +13573,21 @@
                             <a:srgbClr val="FFFFFF"/>
                           </a:solidFill>
                         </a:rPr>
-                        <a:t xml:space="preserve">Sesgo en la media</a:t>
+                        <a:t>Sesgo en la media</a:t>
                       </a:r>
                     </a:p>
                   </a:txBody>
-                  <a:tcPr anchor="ctr" marL="64008" marR="64008" marT="18288" marB="18288">
+                  <a:tcPr marL="64008" marR="64008" marT="18288" marB="18288" anchor="ctr">
                     <a:solidFill>
                       <a:srgbClr val="20236D"/>
                     </a:solidFill>
                   </a:tcPr>
                 </a:tc>
+                <a:extLst>
+                  <a:ext uri="{0D108BD9-81ED-4DB2-BD59-A6C34878D82A}">
+                    <a16:rowId xmlns:a16="http://schemas.microsoft.com/office/drawing/2014/main" val="10000"/>
+                  </a:ext>
+                </a:extLst>
               </a:tr>
               <a:tr h="292608">
                 <a:tc>
@@ -13263,11 +13609,11 @@
                             </a:schemeClr>
                           </a:solidFill>
                         </a:rPr>
-                        <a:t xml:space="preserve">edad_promedio</a:t>
+                        <a:t>edad_promedio</a:t>
                       </a:r>
                     </a:p>
                   </a:txBody>
-                  <a:tcPr anchor="ctr" marL="64008" marR="64008" marT="18288" marB="18288">
+                  <a:tcPr marL="64008" marR="64008" marT="18288" marB="18288" anchor="ctr">
                     <a:lnB w="9525" cap="flat">
                       <a:solidFill>
                         <a:srgbClr val="C9CCDB"/>
@@ -13297,11 +13643,11 @@
                             </a:schemeClr>
                           </a:solidFill>
                         </a:rPr>
-                        <a:t xml:space="preserve">MCAR</a:t>
+                        <a:t>MCAR</a:t>
                       </a:r>
                     </a:p>
                   </a:txBody>
-                  <a:tcPr anchor="ctr" marL="64008" marR="64008" marT="18288" marB="18288">
+                  <a:tcPr marL="64008" marR="64008" marT="18288" marB="18288" anchor="ctr">
                     <a:lnB w="9525" cap="flat">
                       <a:solidFill>
                         <a:srgbClr val="C9CCDB"/>
@@ -13331,11 +13677,11 @@
                             </a:schemeClr>
                           </a:solidFill>
                         </a:rPr>
-                        <a:t xml:space="preserve">14,9 %</a:t>
+                        <a:t>14,9 %</a:t>
                       </a:r>
                     </a:p>
                   </a:txBody>
-                  <a:tcPr anchor="ctr" marL="64008" marR="64008" marT="18288" marB="18288">
+                  <a:tcPr marL="64008" marR="64008" marT="18288" marB="18288" anchor="ctr">
                     <a:lnB w="9525" cap="flat">
                       <a:solidFill>
                         <a:srgbClr val="C9CCDB"/>
@@ -13365,11 +13711,11 @@
                             </a:schemeClr>
                           </a:solidFill>
                         </a:rPr>
-                        <a:t xml:space="preserve">+0,015</a:t>
+                        <a:t>+0,015</a:t>
                       </a:r>
                     </a:p>
                   </a:txBody>
-                  <a:tcPr anchor="ctr" marL="64008" marR="64008" marT="18288" marB="18288">
+                  <a:tcPr marL="64008" marR="64008" marT="18288" marB="18288" anchor="ctr">
                     <a:lnB w="9525" cap="flat">
                       <a:solidFill>
                         <a:srgbClr val="C9CCDB"/>
@@ -13380,6 +13726,11 @@
                     </a:solidFill>
                   </a:tcPr>
                 </a:tc>
+                <a:extLst>
+                  <a:ext uri="{0D108BD9-81ED-4DB2-BD59-A6C34878D82A}">
+                    <a16:rowId xmlns:a16="http://schemas.microsoft.com/office/drawing/2014/main" val="10001"/>
+                  </a:ext>
+                </a:extLst>
               </a:tr>
               <a:tr h="292608">
                 <a:tc>
@@ -13401,11 +13752,20 @@
                             </a:schemeClr>
                           </a:solidFill>
                         </a:rPr>
-                        <a:t xml:space="preserve">pct_mujeres</a:t>
+                        <a:t>pct_mujeres</a:t>
                       </a:r>
                     </a:p>
                   </a:txBody>
-                  <a:tcPr anchor="ctr" marL="64008" marR="64008" marT="18288" marB="18288">
+                  <a:tcPr marL="64008" marR="64008" marT="18288" marB="18288" anchor="ctr">
+                    <a:lnT w="9525" cap="flat" cmpd="sng" algn="ctr">
+                      <a:solidFill>
+                        <a:srgbClr val="C9CCDB"/>
+                      </a:solidFill>
+                      <a:prstDash val="solid"/>
+                      <a:round/>
+                      <a:headEnd type="none" w="med" len="med"/>
+                      <a:tailEnd type="none" w="med" len="med"/>
+                    </a:lnT>
                     <a:lnB w="9525" cap="flat">
                       <a:solidFill>
                         <a:srgbClr val="C9CCDB"/>
@@ -13435,11 +13795,20 @@
                             </a:schemeClr>
                           </a:solidFill>
                         </a:rPr>
-                        <a:t xml:space="preserve">MAR</a:t>
+                        <a:t>MAR</a:t>
                       </a:r>
                     </a:p>
                   </a:txBody>
-                  <a:tcPr anchor="ctr" marL="64008" marR="64008" marT="18288" marB="18288">
+                  <a:tcPr marL="64008" marR="64008" marT="18288" marB="18288" anchor="ctr">
+                    <a:lnT w="9525" cap="flat" cmpd="sng" algn="ctr">
+                      <a:solidFill>
+                        <a:srgbClr val="C9CCDB"/>
+                      </a:solidFill>
+                      <a:prstDash val="solid"/>
+                      <a:round/>
+                      <a:headEnd type="none" w="med" len="med"/>
+                      <a:tailEnd type="none" w="med" len="med"/>
+                    </a:lnT>
                     <a:lnB w="9525" cap="flat">
                       <a:solidFill>
                         <a:srgbClr val="C9CCDB"/>
@@ -13469,11 +13838,20 @@
                             </a:schemeClr>
                           </a:solidFill>
                         </a:rPr>
-                        <a:t xml:space="preserve">24,5 %</a:t>
+                        <a:t>24,5 %</a:t>
                       </a:r>
                     </a:p>
                   </a:txBody>
-                  <a:tcPr anchor="ctr" marL="64008" marR="64008" marT="18288" marB="18288">
+                  <a:tcPr marL="64008" marR="64008" marT="18288" marB="18288" anchor="ctr">
+                    <a:lnT w="9525" cap="flat" cmpd="sng" algn="ctr">
+                      <a:solidFill>
+                        <a:srgbClr val="C9CCDB"/>
+                      </a:solidFill>
+                      <a:prstDash val="solid"/>
+                      <a:round/>
+                      <a:headEnd type="none" w="med" len="med"/>
+                      <a:tailEnd type="none" w="med" len="med"/>
+                    </a:lnT>
                     <a:lnB w="9525" cap="flat">
                       <a:solidFill>
                         <a:srgbClr val="C9CCDB"/>
@@ -13503,11 +13881,20 @@
                             </a:schemeClr>
                           </a:solidFill>
                         </a:rPr>
-                        <a:t xml:space="preserve">−0,002</a:t>
+                        <a:t>−0,002</a:t>
                       </a:r>
                     </a:p>
                   </a:txBody>
-                  <a:tcPr anchor="ctr" marL="64008" marR="64008" marT="18288" marB="18288">
+                  <a:tcPr marL="64008" marR="64008" marT="18288" marB="18288" anchor="ctr">
+                    <a:lnT w="9525" cap="flat" cmpd="sng" algn="ctr">
+                      <a:solidFill>
+                        <a:srgbClr val="C9CCDB"/>
+                      </a:solidFill>
+                      <a:prstDash val="solid"/>
+                      <a:round/>
+                      <a:headEnd type="none" w="med" len="med"/>
+                      <a:tailEnd type="none" w="med" len="med"/>
+                    </a:lnT>
                     <a:lnB w="9525" cap="flat">
                       <a:solidFill>
                         <a:srgbClr val="C9CCDB"/>
@@ -13518,6 +13905,11 @@
                     </a:solidFill>
                   </a:tcPr>
                 </a:tc>
+                <a:extLst>
+                  <a:ext uri="{0D108BD9-81ED-4DB2-BD59-A6C34878D82A}">
+                    <a16:rowId xmlns:a16="http://schemas.microsoft.com/office/drawing/2014/main" val="10002"/>
+                  </a:ext>
+                </a:extLst>
               </a:tr>
               <a:tr h="292608">
                 <a:tc>
@@ -13539,11 +13931,20 @@
                             </a:schemeClr>
                           </a:solidFill>
                         </a:rPr>
-                        <a:t xml:space="preserve">log_matricula</a:t>
+                        <a:t>log_matricula</a:t>
                       </a:r>
                     </a:p>
                   </a:txBody>
-                  <a:tcPr anchor="ctr" marL="64008" marR="64008" marT="18288" marB="18288">
+                  <a:tcPr marL="64008" marR="64008" marT="18288" marB="18288" anchor="ctr">
+                    <a:lnT w="9525" cap="flat" cmpd="sng" algn="ctr">
+                      <a:solidFill>
+                        <a:srgbClr val="C9CCDB"/>
+                      </a:solidFill>
+                      <a:prstDash val="solid"/>
+                      <a:round/>
+                      <a:headEnd type="none" w="med" len="med"/>
+                      <a:tailEnd type="none" w="med" len="med"/>
+                    </a:lnT>
                     <a:lnB w="9525" cap="flat">
                       <a:solidFill>
                         <a:srgbClr val="C9CCDB"/>
@@ -13573,11 +13974,20 @@
                             </a:schemeClr>
                           </a:solidFill>
                         </a:rPr>
-                        <a:t xml:space="preserve">MNAR</a:t>
+                        <a:t>MNAR</a:t>
                       </a:r>
                     </a:p>
                   </a:txBody>
-                  <a:tcPr anchor="ctr" marL="64008" marR="64008" marT="18288" marB="18288">
+                  <a:tcPr marL="64008" marR="64008" marT="18288" marB="18288" anchor="ctr">
+                    <a:lnT w="9525" cap="flat" cmpd="sng" algn="ctr">
+                      <a:solidFill>
+                        <a:srgbClr val="C9CCDB"/>
+                      </a:solidFill>
+                      <a:prstDash val="solid"/>
+                      <a:round/>
+                      <a:headEnd type="none" w="med" len="med"/>
+                      <a:tailEnd type="none" w="med" len="med"/>
+                    </a:lnT>
                     <a:lnB w="9525" cap="flat">
                       <a:solidFill>
                         <a:srgbClr val="C9CCDB"/>
@@ -13607,11 +14017,20 @@
                             </a:schemeClr>
                           </a:solidFill>
                         </a:rPr>
-                        <a:t xml:space="preserve">24,6 %</a:t>
+                        <a:t>24,6 %</a:t>
                       </a:r>
                     </a:p>
                   </a:txBody>
-                  <a:tcPr anchor="ctr" marL="64008" marR="64008" marT="18288" marB="18288">
+                  <a:tcPr marL="64008" marR="64008" marT="18288" marB="18288" anchor="ctr">
+                    <a:lnT w="9525" cap="flat" cmpd="sng" algn="ctr">
+                      <a:solidFill>
+                        <a:srgbClr val="C9CCDB"/>
+                      </a:solidFill>
+                      <a:prstDash val="solid"/>
+                      <a:round/>
+                      <a:headEnd type="none" w="med" len="med"/>
+                      <a:tailEnd type="none" w="med" len="med"/>
+                    </a:lnT>
                     <a:lnB w="9525" cap="flat">
                       <a:solidFill>
                         <a:srgbClr val="C9CCDB"/>
@@ -13641,11 +14060,20 @@
                             </a:schemeClr>
                           </a:solidFill>
                         </a:rPr>
-                        <a:t xml:space="preserve">+0,129</a:t>
+                        <a:t>+0,129</a:t>
                       </a:r>
                     </a:p>
                   </a:txBody>
-                  <a:tcPr anchor="ctr" marL="64008" marR="64008" marT="18288" marB="18288">
+                  <a:tcPr marL="64008" marR="64008" marT="18288" marB="18288" anchor="ctr">
+                    <a:lnT w="9525" cap="flat" cmpd="sng" algn="ctr">
+                      <a:solidFill>
+                        <a:srgbClr val="C9CCDB"/>
+                      </a:solidFill>
+                      <a:prstDash val="solid"/>
+                      <a:round/>
+                      <a:headEnd type="none" w="med" len="med"/>
+                      <a:tailEnd type="none" w="med" len="med"/>
+                    </a:lnT>
                     <a:lnB w="9525" cap="flat">
                       <a:solidFill>
                         <a:srgbClr val="C9CCDB"/>
@@ -13656,6 +14084,11 @@
                     </a:solidFill>
                   </a:tcPr>
                 </a:tc>
+                <a:extLst>
+                  <a:ext uri="{0D108BD9-81ED-4DB2-BD59-A6C34878D82A}">
+                    <a16:rowId xmlns:a16="http://schemas.microsoft.com/office/drawing/2014/main" val="10003"/>
+                  </a:ext>
+                </a:extLst>
               </a:tr>
             </a:tbl>
           </a:graphicData>
@@ -13694,7 +14127,7 @@
                   <a:srgbClr val="20236D"/>
                 </a:solidFill>
               </a:rPr>
-              <a:t xml:space="preserve">El problema</a:t>
+              <a:t>El problema</a:t>
             </a:r>
           </a:p>
           <a:p>
@@ -13712,7 +14145,7 @@
                   </a:schemeClr>
                 </a:solidFill>
               </a:rPr>
-              <a:t xml:space="preserve">La pauta pide imputar datos faltantes y S1 demostró que no hay ninguno. El conjunto no los tuvo nunca: cada fila es un agregado por programa, y un programa sin los campos necesarios no produce una fila con huecos, no produce fila.</a:t>
+              <a:t>La pauta pide imputar datos faltantes y S1 demostró que no hay ninguno. El conjunto no los tuvo nunca: cada fila es un agregado por programa, y un programa sin los campos necesarios no produce una fila con huecos, no produce fila.</a:t>
             </a:r>
           </a:p>
           <a:p>
@@ -13730,7 +14163,7 @@
                   </a:schemeClr>
                 </a:solidFill>
               </a:rPr>
-              <a:t xml:space="preserve">Solución: un experimento controlado de ausencia bajo los tres mecanismos de Rubin. La ventaja es decisiva, porque conocemos los valores verdaderos y podemos medir el error de cada estrategia.</a:t>
+              <a:t>Solución: un experimento controlado de ausencia bajo los tres mecanismos de Rubin. La ventaja es decisiva, porque conocemos los valores verdaderos y podemos medir el error de cada estrategia.</a:t>
             </a:r>
           </a:p>
         </p:txBody>
@@ -13768,7 +14201,7 @@
                   <a:srgbClr val="20236D"/>
                 </a:solidFill>
               </a:rPr>
-              <a:t xml:space="preserve">La lección, y no es la esperada</a:t>
+              <a:t>La lección, y no es la esperada</a:t>
             </a:r>
           </a:p>
           <a:p>
@@ -13788,7 +14221,7 @@
                   </a:schemeClr>
                 </a:solidFill>
               </a:rPr>
-              <a:t xml:space="preserve">Bajo </a:t>
+              <a:t>Bajo </a:t>
             </a:r>
             <a:r>
               <a:rPr lang="es-CL" sz="1250" b="1" i="0" dirty="0">
@@ -13799,7 +14232,7 @@
                   </a:schemeClr>
                 </a:solidFill>
               </a:rPr>
-              <a:t xml:space="preserve">MNAR</a:t>
+              <a:t>MNAR</a:t>
             </a:r>
             <a:r>
               <a:rPr lang="es-CL" sz="1250" b="0" i="0" dirty="0">
@@ -13810,7 +14243,7 @@
                   </a:schemeClr>
                 </a:solidFill>
               </a:rPr>
-              <a:t xml:space="preserve"> el sesgo es grande: faltan los programas pequeños y la media observada sobreestima el tamaño típico.</a:t>
+              <a:t> el sesgo es grande: faltan los programas pequeños y la media observada sobreestima el tamaño típico.</a:t>
             </a:r>
           </a:p>
           <a:p>
@@ -13830,7 +14263,7 @@
                   </a:schemeClr>
                 </a:solidFill>
               </a:rPr>
-              <a:t xml:space="preserve">Bajo </a:t>
+              <a:t>Bajo </a:t>
             </a:r>
             <a:r>
               <a:rPr lang="es-CL" sz="1250" b="1" i="0" dirty="0">
@@ -13841,7 +14274,7 @@
                   </a:schemeClr>
                 </a:solidFill>
               </a:rPr>
-              <a:t xml:space="preserve">MAR</a:t>
+              <a:t>MAR</a:t>
             </a:r>
             <a:r>
               <a:rPr lang="es-CL" sz="1250" b="0" i="0" dirty="0">
@@ -13852,7 +14285,7 @@
                   </a:schemeClr>
                 </a:solidFill>
               </a:rPr>
-              <a:t xml:space="preserve"> el sesgo de la media es despreciable, porque la duración apenas correlaciona con la variable afectada.</a:t>
+              <a:t> el sesgo de la media es despreciable, porque la duración apenas correlaciona con la variable afectada.</a:t>
             </a:r>
           </a:p>
           <a:p>
@@ -13872,7 +14305,7 @@
                   </a:schemeClr>
                 </a:solidFill>
               </a:rPr>
-              <a:t xml:space="preserve">MAR no sesga necesariamente las medias; lo que distorsiona son las relaciones condicionales.</a:t>
+              <a:t>MAR no sesga necesariamente las medias; lo que distorsiona son las relaciones condicionales.</a:t>
             </a:r>
           </a:p>
           <a:p>
@@ -13890,7 +14323,7 @@
                   </a:schemeClr>
                 </a:solidFill>
               </a:rPr>
-              <a:t xml:space="preserve">La pauta prescribe una variable MCAR entre el 10 y el 15 %: es la edad promedio, con 14,9 % y semilla fija. MAR y MNAR los declaramos extensión voluntaria.</a:t>
+              <a:t>La pauta prescribe una variable MCAR entre el 10 y el 15 %: es la edad promedio, con 14,9 % y semilla fija. MAR y MNAR los declaramos extensión voluntaria.</a:t>
             </a:r>
           </a:p>
         </p:txBody>
@@ -13999,7 +14432,7 @@
                   <a:srgbClr val="20236D"/>
                 </a:solidFill>
               </a:rPr>
-              <a:t xml:space="preserve">Hallazgos</a:t>
+              <a:t>Hallazgos</a:t>
             </a:r>
           </a:p>
           <a:p>
@@ -14014,7 +14447,7 @@
                   <a:srgbClr val="20236D"/>
                 </a:solidFill>
               </a:rPr>
-              <a:t xml:space="preserve">Resultados</a:t>
+              <a:t>Resultados</a:t>
             </a:r>
           </a:p>
           <a:p>
@@ -14032,7 +14465,7 @@
                   </a:schemeClr>
                 </a:solidFill>
               </a:rPr>
-              <a:t xml:space="preserve">Cuatro hallazgos: qué imputación gana, qué factores explican el abandono, qué tan bien se predice y cuánta precisión declarábamos de más.</a:t>
+              <a:t>Cuatro hallazgos: qué imputación gana, qué factores explican el abandono, qué tan bien se predice y cuánta precisión declarábamos de más.</a:t>
             </a:r>
           </a:p>
         </p:txBody>
@@ -14562,7 +14995,7 @@
           <p:nvPr/>
         </p:nvPicPr>
         <p:blipFill>
-          <a:blip r:embed="rId2"/>
+          <a:blip r:embed="rId4"/>
           <a:stretch>
             <a:fillRect/>
           </a:stretch>
@@ -14613,7 +15046,7 @@
                   </a:schemeClr>
                 </a:solidFill>
               </a:rPr>
-              <a:t xml:space="preserve">Conserva el </a:t>
+              <a:t>Conserva el </a:t>
             </a:r>
             <a:r>
               <a:rPr lang="es-CL" sz="1300" b="1" i="0" dirty="0">
@@ -14624,7 +15057,7 @@
                   </a:schemeClr>
                 </a:solidFill>
               </a:rPr>
-              <a:t xml:space="preserve">100 % de la muestra</a:t>
+              <a:t>100 % de la muestra</a:t>
             </a:r>
             <a:r>
               <a:rPr lang="es-CL" sz="1300" b="0" i="0" dirty="0">
@@ -14635,7 +15068,7 @@
                   </a:schemeClr>
                 </a:solidFill>
               </a:rPr>
-              <a:t xml:space="preserve"> frente al 47,5 % que deja la eliminación; su desvío respecto de las correlaciones de S1 es el menor de los tres (0,0135 contra 0,0183 y 0,0197); y su RMSE es menor en las tres variables. Pero bajo MNAR ninguna estrategia recupera lo perdido: el sesgo persiste.</a:t>
+              <a:t> frente al 47,5 % que deja la eliminación; su desvío respecto de las correlaciones de S1 es el menor de los tres (0,0135 contra 0,0183 y 0,0197); y su RMSE es menor en las tres variables. Pero bajo MNAR ninguna estrategia recupera lo perdido: el sesgo persiste.</a:t>
             </a:r>
           </a:p>
         </p:txBody>
@@ -14970,7 +15403,7 @@
         </p:xfrm>
         <a:graphic>
           <a:graphicData uri="http://schemas.openxmlformats.org/drawingml/2006/chart">
-            <c:chart xmlns:c="http://schemas.openxmlformats.org/drawingml/2006/chart" r:id="rId2"/>
+            <c:chart xmlns:c="http://schemas.openxmlformats.org/drawingml/2006/chart" xmlns:r="http://schemas.openxmlformats.org/officeDocument/2006/relationships" r:id="rId4"/>
           </a:graphicData>
         </a:graphic>
       </p:graphicFrame>
@@ -15007,7 +15440,7 @@
                   <a:srgbClr val="20236D"/>
                 </a:solidFill>
               </a:rPr>
-              <a:t xml:space="preserve">Cómo se lee</a:t>
+              <a:t>Cómo se lee</a:t>
             </a:r>
           </a:p>
           <a:p>
@@ -15025,7 +15458,7 @@
                   </a:schemeClr>
                 </a:solidFill>
               </a:rPr>
-              <a:t xml:space="preserve">Las variables están estandarizadas, así que cada razón de momios es el efecto de </a:t>
+              <a:t>Las variables están estandarizadas, así que cada razón de momios es el efecto de </a:t>
             </a:r>
             <a:r>
               <a:rPr lang="es-CL" sz="1250" b="1" i="0" dirty="0">
@@ -15036,7 +15469,7 @@
                   </a:schemeClr>
                 </a:solidFill>
               </a:rPr>
-              <a:t xml:space="preserve">una desviación típica</a:t>
+              <a:t>una desviación típica</a:t>
             </a:r>
             <a:r>
               <a:rPr lang="es-CL" sz="1250" b="0" i="0" dirty="0">
@@ -15047,7 +15480,7 @@
                   </a:schemeClr>
                 </a:solidFill>
               </a:rPr>
-              <a:t xml:space="preserve">. Un valor bajo 1 reduce el riesgo.</a:t>
+              <a:t>. Un valor bajo 1 reduce el riesgo.</a:t>
             </a:r>
           </a:p>
           <a:p>
@@ -15065,7 +15498,7 @@
                   </a:schemeClr>
                 </a:solidFill>
               </a:rPr>
-              <a:t xml:space="preserve">Una desviación típica más de acreditación, tamaño o presencia femenina reduce </a:t>
+              <a:t>Una desviación típica más de acreditación, tamaño o presencia femenina reduce </a:t>
             </a:r>
             <a:r>
               <a:rPr lang="es-CL" sz="1250" b="1" i="0" dirty="0">
@@ -15076,7 +15509,7 @@
                   </a:schemeClr>
                 </a:solidFill>
               </a:rPr>
-              <a:t xml:space="preserve">entre un 24 % y un 37 %</a:t>
+              <a:t>entre un 24 % y un 37 %</a:t>
             </a:r>
             <a:r>
               <a:rPr lang="es-CL" sz="1250" b="0" i="0" dirty="0">
@@ -15087,7 +15520,7 @@
                   </a:schemeClr>
                 </a:solidFill>
               </a:rPr>
-              <a:t xml:space="preserve"> la probabilidad relativa de abandono alto.</a:t>
+              <a:t> la probabilidad relativa de abandono alto.</a:t>
             </a:r>
           </a:p>
           <a:p>
@@ -15105,7 +15538,7 @@
                   </a:schemeClr>
                 </a:solidFill>
               </a:rPr>
-              <a:t xml:space="preserve">Las cuatro son significativas al 0,1 %, y cada una entra al modelo con su cifra de S1 y su intervalo de S2.</a:t>
+              <a:t>Las cuatro son significativas al 0,1 %, y cada una entra al modelo con su cifra de S1 y su intervalo de S2.</a:t>
             </a:r>
           </a:p>
         </p:txBody>
@@ -15146,7 +15579,7 @@
                   </a:schemeClr>
                 </a:solidFill>
               </a:rPr>
-              <a:t xml:space="preserve">Las tres selecciones de variables (dominio, stepwise por AIC y reducida) retienen exactamente estas cuatro continuas.</a:t>
+              <a:t>Las tres selecciones de variables (dominio, stepwise por AIC y reducida) retienen exactamente estas cuatro continuas.</a:t>
             </a:r>
           </a:p>
         </p:txBody>

</xml_diff>